<commit_message>
actualizo memoria y presentacion con los tests automatizados
- cambio el dafo: ya no es debilidad la ausencia de tests, ahora el punto
  es que faltan tests unitarios sobre los modelos
- añado en la seccion de pruebas el apartado de los 25 tests de integracion
  con node:test y supertest antes de los casos manuales
- quito 'pruebas automatizadas' de vias futuras porque ya estan hechas,
  lo cambio por pruebas unitarias que es lo que faltaria
- actualizo la presentacion: slide 13 con los 25 tests reales y slide 14
  con la referencia correcta en las conclusiones
</commit_message>
<xml_diff>
--- a/MindTracker_Presentacion.pptx
+++ b/MindTracker_Presentacion.pptx
@@ -3316,7 +3316,7 @@
             <a:avLst/>
           </a:prstGeom>
           <a:solidFill>
-            <a:srgbClr val="4AA86C"/>
+            <a:srgbClr val="5BBCDD"/>
           </a:solidFill>
           <a:ln>
             <a:noFill/>
@@ -3756,7 +3756,7 @@
             <a:avLst/>
           </a:prstGeom>
           <a:solidFill>
-            <a:srgbClr val="4AA86C"/>
+            <a:srgbClr val="5BBCDD"/>
           </a:solidFill>
           <a:ln>
             <a:noFill/>
@@ -3834,7 +3834,7 @@
             <a:avLst/>
           </a:prstGeom>
           <a:solidFill>
-            <a:srgbClr val="4AA86C"/>
+            <a:srgbClr val="5BBCDD"/>
           </a:solidFill>
           <a:ln>
             <a:noFill/>
@@ -3912,7 +3912,7 @@
             <a:avLst/>
           </a:prstGeom>
           <a:solidFill>
-            <a:srgbClr val="4AA86C"/>
+            <a:srgbClr val="5BBCDD"/>
           </a:solidFill>
           <a:ln>
             <a:noFill/>
@@ -3990,7 +3990,7 @@
             <a:avLst/>
           </a:prstGeom>
           <a:solidFill>
-            <a:srgbClr val="4AA86C"/>
+            <a:srgbClr val="5BBCDD"/>
           </a:solidFill>
           <a:ln>
             <a:noFill/>
@@ -4232,7 +4232,7 @@
             <a:avLst/>
           </a:prstGeom>
           <a:solidFill>
-            <a:srgbClr val="4AA86C"/>
+            <a:srgbClr val="5BBCDD"/>
           </a:solidFill>
           <a:ln>
             <a:noFill/>
@@ -4311,7 +4311,7 @@
             <a:avLst/>
           </a:prstGeom>
           <a:solidFill>
-            <a:srgbClr val="4AA86C"/>
+            <a:srgbClr val="5BBCDD"/>
           </a:solidFill>
           <a:ln>
             <a:noFill/>
@@ -4389,7 +4389,7 @@
             <a:avLst/>
           </a:prstGeom>
           <a:solidFill>
-            <a:srgbClr val="4AA86C"/>
+            <a:srgbClr val="5BBCDD"/>
           </a:solidFill>
           <a:ln>
             <a:noFill/>
@@ -4467,7 +4467,7 @@
             <a:avLst/>
           </a:prstGeom>
           <a:solidFill>
-            <a:srgbClr val="4AA86C"/>
+            <a:srgbClr val="5BBCDD"/>
           </a:solidFill>
           <a:ln>
             <a:noFill/>
@@ -4709,7 +4709,7 @@
             <a:avLst/>
           </a:prstGeom>
           <a:solidFill>
-            <a:srgbClr val="4AA86C"/>
+            <a:srgbClr val="5BBCDD"/>
           </a:solidFill>
           <a:ln>
             <a:noFill/>
@@ -4787,7 +4787,7 @@
             <a:avLst/>
           </a:prstGeom>
           <a:solidFill>
-            <a:srgbClr val="4AA86C"/>
+            <a:srgbClr val="5BBCDD"/>
           </a:solidFill>
           <a:ln>
             <a:noFill/>
@@ -4865,7 +4865,7 @@
             <a:avLst/>
           </a:prstGeom>
           <a:solidFill>
-            <a:srgbClr val="4AA86C"/>
+            <a:srgbClr val="5BBCDD"/>
           </a:solidFill>
           <a:ln>
             <a:noFill/>
@@ -4943,7 +4943,7 @@
             <a:avLst/>
           </a:prstGeom>
           <a:solidFill>
-            <a:srgbClr val="4AA86C"/>
+            <a:srgbClr val="5BBCDD"/>
           </a:solidFill>
           <a:ln>
             <a:noFill/>
@@ -7301,7 +7301,7 @@
                 </a:solidFill>
                 <a:latin typeface="Helvetica Neue"/>
               </a:rPr>
-              <a:t>14 casos de prueba documentados · todos superados ✓</a:t>
+              <a:t>25 tests de integración automatizados · todos superados ✓</a:t>
             </a:r>
           </a:p>
         </p:txBody>
@@ -7315,28 +7315,28 @@
         <p:spPr>
           <a:xfrm>
             <a:off x="1005840" y="2011680"/>
-            <a:ext cx="822960" cy="475488"/>
-          </a:xfrm>
-          <a:prstGeom prst="rect">
-            <a:avLst/>
-          </a:prstGeom>
-          <a:noFill/>
-        </p:spPr>
-        <p:txBody>
-          <a:bodyPr wrap="square">
-            <a:spAutoFit/>
-          </a:bodyPr>
-          <a:lstStyle/>
-          <a:p>
-            <a:pPr algn="l"/>
-            <a:r>
-              <a:rPr sz="950" b="1" i="0">
+            <a:ext cx="822960" cy="292608"/>
+          </a:xfrm>
+          <a:prstGeom prst="rect">
+            <a:avLst/>
+          </a:prstGeom>
+          <a:noFill/>
+        </p:spPr>
+        <p:txBody>
+          <a:bodyPr wrap="square">
+            <a:spAutoFit/>
+          </a:bodyPr>
+          <a:lstStyle/>
+          <a:p>
+            <a:pPr algn="l"/>
+            <a:r>
+              <a:rPr sz="850" b="1" i="0">
                 <a:solidFill>
                   <a:srgbClr val="2C6E49"/>
                 </a:solidFill>
                 <a:latin typeface="Helvetica Neue"/>
               </a:rPr>
-              <a:t>CP-01</a:t>
+              <a:t>T-01</a:t>
             </a:r>
           </a:p>
         </p:txBody>
@@ -7350,28 +7350,28 @@
         <p:spPr>
           <a:xfrm>
             <a:off x="1828800" y="2011680"/>
-            <a:ext cx="4572000" cy="475488"/>
-          </a:xfrm>
-          <a:prstGeom prst="rect">
-            <a:avLst/>
-          </a:prstGeom>
-          <a:noFill/>
-        </p:spPr>
-        <p:txBody>
-          <a:bodyPr wrap="square">
-            <a:spAutoFit/>
-          </a:bodyPr>
-          <a:lstStyle/>
-          <a:p>
-            <a:pPr algn="l"/>
-            <a:r>
-              <a:rPr sz="1050" b="0" i="0">
+            <a:ext cx="4572000" cy="292608"/>
+          </a:xfrm>
+          <a:prstGeom prst="rect">
+            <a:avLst/>
+          </a:prstGeom>
+          <a:noFill/>
+        </p:spPr>
+        <p:txBody>
+          <a:bodyPr wrap="square">
+            <a:spAutoFit/>
+          </a:bodyPr>
+          <a:lstStyle/>
+          <a:p>
+            <a:pPr algn="l"/>
+            <a:r>
+              <a:rPr sz="950" b="0" i="0">
                 <a:solidFill>
                   <a:srgbClr val="1C1C1E"/>
                 </a:solidFill>
                 <a:latin typeface="Helvetica Neue"/>
               </a:rPr>
-              <a:t>Registro de nuevo usuario con datos válidos</a:t>
+              <a:t>Registro de usuario → 201</a:t>
             </a:r>
           </a:p>
         </p:txBody>
@@ -7385,7 +7385,7 @@
         <p:spPr>
           <a:xfrm>
             <a:off x="6400800" y="2011680"/>
-            <a:ext cx="365760" cy="475488"/>
+            <a:ext cx="365760" cy="292608"/>
           </a:xfrm>
           <a:prstGeom prst="rect">
             <a:avLst/>
@@ -7400,7 +7400,7 @@
           <a:p>
             <a:pPr algn="ctr"/>
             <a:r>
-              <a:rPr sz="1000" b="1" i="0">
+              <a:rPr sz="900" b="1" i="0">
                 <a:solidFill>
                   <a:srgbClr val="2C6E49"/>
                 </a:solidFill>
@@ -7419,29 +7419,29 @@
         </p:nvSpPr>
         <p:spPr>
           <a:xfrm>
-            <a:off x="1005840" y="2560320"/>
-            <a:ext cx="822960" cy="475488"/>
-          </a:xfrm>
-          <a:prstGeom prst="rect">
-            <a:avLst/>
-          </a:prstGeom>
-          <a:noFill/>
-        </p:spPr>
-        <p:txBody>
-          <a:bodyPr wrap="square">
-            <a:spAutoFit/>
-          </a:bodyPr>
-          <a:lstStyle/>
-          <a:p>
-            <a:pPr algn="l"/>
-            <a:r>
-              <a:rPr sz="950" b="1" i="0">
+            <a:off x="1005840" y="2331720"/>
+            <a:ext cx="822960" cy="292608"/>
+          </a:xfrm>
+          <a:prstGeom prst="rect">
+            <a:avLst/>
+          </a:prstGeom>
+          <a:noFill/>
+        </p:spPr>
+        <p:txBody>
+          <a:bodyPr wrap="square">
+            <a:spAutoFit/>
+          </a:bodyPr>
+          <a:lstStyle/>
+          <a:p>
+            <a:pPr algn="l"/>
+            <a:r>
+              <a:rPr sz="850" b="1" i="0">
                 <a:solidFill>
                   <a:srgbClr val="2C6E49"/>
                 </a:solidFill>
                 <a:latin typeface="Helvetica Neue"/>
               </a:rPr>
-              <a:t>CP-02</a:t>
+              <a:t>T-02</a:t>
             </a:r>
           </a:p>
         </p:txBody>
@@ -7454,29 +7454,29 @@
         </p:nvSpPr>
         <p:spPr>
           <a:xfrm>
-            <a:off x="1828800" y="2560320"/>
-            <a:ext cx="4572000" cy="475488"/>
-          </a:xfrm>
-          <a:prstGeom prst="rect">
-            <a:avLst/>
-          </a:prstGeom>
-          <a:noFill/>
-        </p:spPr>
-        <p:txBody>
-          <a:bodyPr wrap="square">
-            <a:spAutoFit/>
-          </a:bodyPr>
-          <a:lstStyle/>
-          <a:p>
-            <a:pPr algn="l"/>
-            <a:r>
-              <a:rPr sz="1050" b="0" i="0">
+            <a:off x="1828800" y="2331720"/>
+            <a:ext cx="4572000" cy="292608"/>
+          </a:xfrm>
+          <a:prstGeom prst="rect">
+            <a:avLst/>
+          </a:prstGeom>
+          <a:noFill/>
+        </p:spPr>
+        <p:txBody>
+          <a:bodyPr wrap="square">
+            <a:spAutoFit/>
+          </a:bodyPr>
+          <a:lstStyle/>
+          <a:p>
+            <a:pPr algn="l"/>
+            <a:r>
+              <a:rPr sz="950" b="0" i="0">
                 <a:solidFill>
                   <a:srgbClr val="1C1C1E"/>
                 </a:solidFill>
                 <a:latin typeface="Helvetica Neue"/>
               </a:rPr>
-              <a:t>Registro con email duplicado — error esperado</a:t>
+              <a:t>Email duplicado → 400</a:t>
             </a:r>
           </a:p>
         </p:txBody>
@@ -7489,8 +7489,8 @@
         </p:nvSpPr>
         <p:spPr>
           <a:xfrm>
-            <a:off x="6400800" y="2560320"/>
-            <a:ext cx="365760" cy="475488"/>
+            <a:off x="6400800" y="2331720"/>
+            <a:ext cx="365760" cy="292608"/>
           </a:xfrm>
           <a:prstGeom prst="rect">
             <a:avLst/>
@@ -7505,7 +7505,7 @@
           <a:p>
             <a:pPr algn="ctr"/>
             <a:r>
-              <a:rPr sz="1000" b="1" i="0">
+              <a:rPr sz="900" b="1" i="0">
                 <a:solidFill>
                   <a:srgbClr val="2C6E49"/>
                 </a:solidFill>
@@ -7524,29 +7524,29 @@
         </p:nvSpPr>
         <p:spPr>
           <a:xfrm>
-            <a:off x="1005840" y="3108960"/>
-            <a:ext cx="822960" cy="475488"/>
-          </a:xfrm>
-          <a:prstGeom prst="rect">
-            <a:avLst/>
-          </a:prstGeom>
-          <a:noFill/>
-        </p:spPr>
-        <p:txBody>
-          <a:bodyPr wrap="square">
-            <a:spAutoFit/>
-          </a:bodyPr>
-          <a:lstStyle/>
-          <a:p>
-            <a:pPr algn="l"/>
-            <a:r>
-              <a:rPr sz="950" b="1" i="0">
+            <a:off x="1005840" y="2651760"/>
+            <a:ext cx="822960" cy="292608"/>
+          </a:xfrm>
+          <a:prstGeom prst="rect">
+            <a:avLst/>
+          </a:prstGeom>
+          <a:noFill/>
+        </p:spPr>
+        <p:txBody>
+          <a:bodyPr wrap="square">
+            <a:spAutoFit/>
+          </a:bodyPr>
+          <a:lstStyle/>
+          <a:p>
+            <a:pPr algn="l"/>
+            <a:r>
+              <a:rPr sz="850" b="1" i="0">
                 <a:solidFill>
                   <a:srgbClr val="2C6E49"/>
                 </a:solidFill>
                 <a:latin typeface="Helvetica Neue"/>
               </a:rPr>
-              <a:t>CP-03</a:t>
+              <a:t>T-03</a:t>
             </a:r>
           </a:p>
         </p:txBody>
@@ -7559,29 +7559,29 @@
         </p:nvSpPr>
         <p:spPr>
           <a:xfrm>
-            <a:off x="1828800" y="3108960"/>
-            <a:ext cx="4572000" cy="475488"/>
-          </a:xfrm>
-          <a:prstGeom prst="rect">
-            <a:avLst/>
-          </a:prstGeom>
-          <a:noFill/>
-        </p:spPr>
-        <p:txBody>
-          <a:bodyPr wrap="square">
-            <a:spAutoFit/>
-          </a:bodyPr>
-          <a:lstStyle/>
-          <a:p>
-            <a:pPr algn="l"/>
-            <a:r>
-              <a:rPr sz="1050" b="0" i="0">
+            <a:off x="1828800" y="2651760"/>
+            <a:ext cx="4572000" cy="292608"/>
+          </a:xfrm>
+          <a:prstGeom prst="rect">
+            <a:avLst/>
+          </a:prstGeom>
+          <a:noFill/>
+        </p:spPr>
+        <p:txBody>
+          <a:bodyPr wrap="square">
+            <a:spAutoFit/>
+          </a:bodyPr>
+          <a:lstStyle/>
+          <a:p>
+            <a:pPr algn="l"/>
+            <a:r>
+              <a:rPr sz="950" b="0" i="0">
                 <a:solidFill>
                   <a:srgbClr val="1C1C1E"/>
                 </a:solidFill>
                 <a:latin typeface="Helvetica Neue"/>
               </a:rPr>
-              <a:t>Login con credenciales correctas</a:t>
+              <a:t>Registro sin campos → 400</a:t>
             </a:r>
           </a:p>
         </p:txBody>
@@ -7594,8 +7594,8 @@
         </p:nvSpPr>
         <p:spPr>
           <a:xfrm>
-            <a:off x="6400800" y="3108960"/>
-            <a:ext cx="365760" cy="475488"/>
+            <a:off x="6400800" y="2651760"/>
+            <a:ext cx="365760" cy="292608"/>
           </a:xfrm>
           <a:prstGeom prst="rect">
             <a:avLst/>
@@ -7610,7 +7610,7 @@
           <a:p>
             <a:pPr algn="ctr"/>
             <a:r>
-              <a:rPr sz="1000" b="1" i="0">
+              <a:rPr sz="900" b="1" i="0">
                 <a:solidFill>
                   <a:srgbClr val="2C6E49"/>
                 </a:solidFill>
@@ -7629,29 +7629,29 @@
         </p:nvSpPr>
         <p:spPr>
           <a:xfrm>
-            <a:off x="1005840" y="3657600"/>
-            <a:ext cx="822960" cy="475488"/>
-          </a:xfrm>
-          <a:prstGeom prst="rect">
-            <a:avLst/>
-          </a:prstGeom>
-          <a:noFill/>
-        </p:spPr>
-        <p:txBody>
-          <a:bodyPr wrap="square">
-            <a:spAutoFit/>
-          </a:bodyPr>
-          <a:lstStyle/>
-          <a:p>
-            <a:pPr algn="l"/>
-            <a:r>
-              <a:rPr sz="950" b="1" i="0">
+            <a:off x="1005840" y="2971800"/>
+            <a:ext cx="822960" cy="292608"/>
+          </a:xfrm>
+          <a:prstGeom prst="rect">
+            <a:avLst/>
+          </a:prstGeom>
+          <a:noFill/>
+        </p:spPr>
+        <p:txBody>
+          <a:bodyPr wrap="square">
+            <a:spAutoFit/>
+          </a:bodyPr>
+          <a:lstStyle/>
+          <a:p>
+            <a:pPr algn="l"/>
+            <a:r>
+              <a:rPr sz="850" b="1" i="0">
                 <a:solidFill>
                   <a:srgbClr val="2C6E49"/>
                 </a:solidFill>
                 <a:latin typeface="Helvetica Neue"/>
               </a:rPr>
-              <a:t>CP-04</a:t>
+              <a:t>T-04</a:t>
             </a:r>
           </a:p>
         </p:txBody>
@@ -7664,29 +7664,29 @@
         </p:nvSpPr>
         <p:spPr>
           <a:xfrm>
-            <a:off x="1828800" y="3657600"/>
-            <a:ext cx="4572000" cy="475488"/>
-          </a:xfrm>
-          <a:prstGeom prst="rect">
-            <a:avLst/>
-          </a:prstGeom>
-          <a:noFill/>
-        </p:spPr>
-        <p:txBody>
-          <a:bodyPr wrap="square">
-            <a:spAutoFit/>
-          </a:bodyPr>
-          <a:lstStyle/>
-          <a:p>
-            <a:pPr algn="l"/>
-            <a:r>
-              <a:rPr sz="1050" b="0" i="0">
+            <a:off x="1828800" y="2971800"/>
+            <a:ext cx="4572000" cy="292608"/>
+          </a:xfrm>
+          <a:prstGeom prst="rect">
+            <a:avLst/>
+          </a:prstGeom>
+          <a:noFill/>
+        </p:spPr>
+        <p:txBody>
+          <a:bodyPr wrap="square">
+            <a:spAutoFit/>
+          </a:bodyPr>
+          <a:lstStyle/>
+          <a:p>
+            <a:pPr algn="l"/>
+            <a:r>
+              <a:rPr sz="950" b="0" i="0">
                 <a:solidFill>
                   <a:srgbClr val="1C1C1E"/>
                 </a:solidFill>
                 <a:latin typeface="Helvetica Neue"/>
               </a:rPr>
-              <a:t>Login con contraseña incorrecta — error esperado</a:t>
+              <a:t>Login correcto → cookie JWT</a:t>
             </a:r>
           </a:p>
         </p:txBody>
@@ -7699,8 +7699,8 @@
         </p:nvSpPr>
         <p:spPr>
           <a:xfrm>
-            <a:off x="6400800" y="3657600"/>
-            <a:ext cx="365760" cy="475488"/>
+            <a:off x="6400800" y="2971800"/>
+            <a:ext cx="365760" cy="292608"/>
           </a:xfrm>
           <a:prstGeom prst="rect">
             <a:avLst/>
@@ -7715,7 +7715,7 @@
           <a:p>
             <a:pPr algn="ctr"/>
             <a:r>
-              <a:rPr sz="1000" b="1" i="0">
+              <a:rPr sz="900" b="1" i="0">
                 <a:solidFill>
                   <a:srgbClr val="2C6E49"/>
                 </a:solidFill>
@@ -7734,29 +7734,29 @@
         </p:nvSpPr>
         <p:spPr>
           <a:xfrm>
-            <a:off x="1005840" y="4206240"/>
-            <a:ext cx="822960" cy="475488"/>
-          </a:xfrm>
-          <a:prstGeom prst="rect">
-            <a:avLst/>
-          </a:prstGeom>
-          <a:noFill/>
-        </p:spPr>
-        <p:txBody>
-          <a:bodyPr wrap="square">
-            <a:spAutoFit/>
-          </a:bodyPr>
-          <a:lstStyle/>
-          <a:p>
-            <a:pPr algn="l"/>
-            <a:r>
-              <a:rPr sz="950" b="1" i="0">
+            <a:off x="1005840" y="3291840"/>
+            <a:ext cx="822960" cy="292608"/>
+          </a:xfrm>
+          <a:prstGeom prst="rect">
+            <a:avLst/>
+          </a:prstGeom>
+          <a:noFill/>
+        </p:spPr>
+        <p:txBody>
+          <a:bodyPr wrap="square">
+            <a:spAutoFit/>
+          </a:bodyPr>
+          <a:lstStyle/>
+          <a:p>
+            <a:pPr algn="l"/>
+            <a:r>
+              <a:rPr sz="850" b="1" i="0">
                 <a:solidFill>
                   <a:srgbClr val="2C6E49"/>
                 </a:solidFill>
                 <a:latin typeface="Helvetica Neue"/>
               </a:rPr>
-              <a:t>CP-05</a:t>
+              <a:t>T-05</a:t>
             </a:r>
           </a:p>
         </p:txBody>
@@ -7769,29 +7769,29 @@
         </p:nvSpPr>
         <p:spPr>
           <a:xfrm>
-            <a:off x="1828800" y="4206240"/>
-            <a:ext cx="4572000" cy="475488"/>
-          </a:xfrm>
-          <a:prstGeom prst="rect">
-            <a:avLst/>
-          </a:prstGeom>
-          <a:noFill/>
-        </p:spPr>
-        <p:txBody>
-          <a:bodyPr wrap="square">
-            <a:spAutoFit/>
-          </a:bodyPr>
-          <a:lstStyle/>
-          <a:p>
-            <a:pPr algn="l"/>
-            <a:r>
-              <a:rPr sz="1050" b="0" i="0">
+            <a:off x="1828800" y="3291840"/>
+            <a:ext cx="4572000" cy="292608"/>
+          </a:xfrm>
+          <a:prstGeom prst="rect">
+            <a:avLst/>
+          </a:prstGeom>
+          <a:noFill/>
+        </p:spPr>
+        <p:txBody>
+          <a:bodyPr wrap="square">
+            <a:spAutoFit/>
+          </a:bodyPr>
+          <a:lstStyle/>
+          <a:p>
+            <a:pPr algn="l"/>
+            <a:r>
+              <a:rPr sz="950" b="0" i="0">
                 <a:solidFill>
                   <a:srgbClr val="1C1C1E"/>
                 </a:solidFill>
                 <a:latin typeface="Helvetica Neue"/>
               </a:rPr>
-              <a:t>Acceso a ruta protegida sin sesión — redirección</a:t>
+              <a:t>Contraseña incorrecta → 400</a:t>
             </a:r>
           </a:p>
         </p:txBody>
@@ -7804,8 +7804,8 @@
         </p:nvSpPr>
         <p:spPr>
           <a:xfrm>
-            <a:off x="6400800" y="4206240"/>
-            <a:ext cx="365760" cy="475488"/>
+            <a:off x="6400800" y="3291840"/>
+            <a:ext cx="365760" cy="292608"/>
           </a:xfrm>
           <a:prstGeom prst="rect">
             <a:avLst/>
@@ -7820,7 +7820,7 @@
           <a:p>
             <a:pPr algn="ctr"/>
             <a:r>
-              <a:rPr sz="1000" b="1" i="0">
+              <a:rPr sz="900" b="1" i="0">
                 <a:solidFill>
                   <a:srgbClr val="2C6E49"/>
                 </a:solidFill>
@@ -7839,29 +7839,29 @@
         </p:nvSpPr>
         <p:spPr>
           <a:xfrm>
-            <a:off x="1005840" y="4754880"/>
-            <a:ext cx="822960" cy="475488"/>
-          </a:xfrm>
-          <a:prstGeom prst="rect">
-            <a:avLst/>
-          </a:prstGeom>
-          <a:noFill/>
-        </p:spPr>
-        <p:txBody>
-          <a:bodyPr wrap="square">
-            <a:spAutoFit/>
-          </a:bodyPr>
-          <a:lstStyle/>
-          <a:p>
-            <a:pPr algn="l"/>
-            <a:r>
-              <a:rPr sz="950" b="1" i="0">
+            <a:off x="1005840" y="3611880"/>
+            <a:ext cx="822960" cy="292608"/>
+          </a:xfrm>
+          <a:prstGeom prst="rect">
+            <a:avLst/>
+          </a:prstGeom>
+          <a:noFill/>
+        </p:spPr>
+        <p:txBody>
+          <a:bodyPr wrap="square">
+            <a:spAutoFit/>
+          </a:bodyPr>
+          <a:lstStyle/>
+          <a:p>
+            <a:pPr algn="l"/>
+            <a:r>
+              <a:rPr sz="850" b="1" i="0">
                 <a:solidFill>
                   <a:srgbClr val="2C6E49"/>
                 </a:solidFill>
                 <a:latin typeface="Helvetica Neue"/>
               </a:rPr>
-              <a:t>CP-06</a:t>
+              <a:t>T-06</a:t>
             </a:r>
           </a:p>
         </p:txBody>
@@ -7874,29 +7874,29 @@
         </p:nvSpPr>
         <p:spPr>
           <a:xfrm>
-            <a:off x="1828800" y="4754880"/>
-            <a:ext cx="4572000" cy="475488"/>
-          </a:xfrm>
-          <a:prstGeom prst="rect">
-            <a:avLst/>
-          </a:prstGeom>
-          <a:noFill/>
-        </p:spPr>
-        <p:txBody>
-          <a:bodyPr wrap="square">
-            <a:spAutoFit/>
-          </a:bodyPr>
-          <a:lstStyle/>
-          <a:p>
-            <a:pPr algn="l"/>
-            <a:r>
-              <a:rPr sz="1050" b="0" i="0">
+            <a:off x="1828800" y="3611880"/>
+            <a:ext cx="4572000" cy="292608"/>
+          </a:xfrm>
+          <a:prstGeom prst="rect">
+            <a:avLst/>
+          </a:prstGeom>
+          <a:noFill/>
+        </p:spPr>
+        <p:txBody>
+          <a:bodyPr wrap="square">
+            <a:spAutoFit/>
+          </a:bodyPr>
+          <a:lstStyle/>
+          <a:p>
+            <a:pPr algn="l"/>
+            <a:r>
+              <a:rPr sz="950" b="0" i="0">
                 <a:solidFill>
                   <a:srgbClr val="1C1C1E"/>
                 </a:solidFill>
                 <a:latin typeface="Helvetica Neue"/>
               </a:rPr>
-              <a:t>Registro de estado de ánimo en fecha actual</a:t>
+              <a:t>Usuario no existe → 400</a:t>
             </a:r>
           </a:p>
         </p:txBody>
@@ -7909,8 +7909,8 @@
         </p:nvSpPr>
         <p:spPr>
           <a:xfrm>
-            <a:off x="6400800" y="4754880"/>
-            <a:ext cx="365760" cy="475488"/>
+            <a:off x="6400800" y="3611880"/>
+            <a:ext cx="365760" cy="292608"/>
           </a:xfrm>
           <a:prstGeom prst="rect">
             <a:avLst/>
@@ -7925,7 +7925,7 @@
           <a:p>
             <a:pPr algn="ctr"/>
             <a:r>
-              <a:rPr sz="1000" b="1" i="0">
+              <a:rPr sz="900" b="1" i="0">
                 <a:solidFill>
                   <a:srgbClr val="2C6E49"/>
                 </a:solidFill>
@@ -7944,29 +7944,29 @@
         </p:nvSpPr>
         <p:spPr>
           <a:xfrm>
-            <a:off x="1005840" y="5303520"/>
-            <a:ext cx="822960" cy="475488"/>
-          </a:xfrm>
-          <a:prstGeom prst="rect">
-            <a:avLst/>
-          </a:prstGeom>
-          <a:noFill/>
-        </p:spPr>
-        <p:txBody>
-          <a:bodyPr wrap="square">
-            <a:spAutoFit/>
-          </a:bodyPr>
-          <a:lstStyle/>
-          <a:p>
-            <a:pPr algn="l"/>
-            <a:r>
-              <a:rPr sz="950" b="1" i="0">
+            <a:off x="1005840" y="3931920"/>
+            <a:ext cx="822960" cy="292608"/>
+          </a:xfrm>
+          <a:prstGeom prst="rect">
+            <a:avLst/>
+          </a:prstGeom>
+          <a:noFill/>
+        </p:spPr>
+        <p:txBody>
+          <a:bodyPr wrap="square">
+            <a:spAutoFit/>
+          </a:bodyPr>
+          <a:lstStyle/>
+          <a:p>
+            <a:pPr algn="l"/>
+            <a:r>
+              <a:rPr sz="850" b="1" i="0">
                 <a:solidFill>
                   <a:srgbClr val="2C6E49"/>
                 </a:solidFill>
                 <a:latin typeface="Helvetica Neue"/>
               </a:rPr>
-              <a:t>CP-07</a:t>
+              <a:t>T-07</a:t>
             </a:r>
           </a:p>
         </p:txBody>
@@ -7979,29 +7979,29 @@
         </p:nvSpPr>
         <p:spPr>
           <a:xfrm>
-            <a:off x="1828800" y="5303520"/>
-            <a:ext cx="4572000" cy="475488"/>
-          </a:xfrm>
-          <a:prstGeom prst="rect">
-            <a:avLst/>
-          </a:prstGeom>
-          <a:noFill/>
-        </p:spPr>
-        <p:txBody>
-          <a:bodyPr wrap="square">
-            <a:spAutoFit/>
-          </a:bodyPr>
-          <a:lstStyle/>
-          <a:p>
-            <a:pPr algn="l"/>
-            <a:r>
-              <a:rPr sz="1050" b="0" i="0">
+            <a:off x="1828800" y="3931920"/>
+            <a:ext cx="4572000" cy="292608"/>
+          </a:xfrm>
+          <a:prstGeom prst="rect">
+            <a:avLst/>
+          </a:prstGeom>
+          <a:noFill/>
+        </p:spPr>
+        <p:txBody>
+          <a:bodyPr wrap="square">
+            <a:spAutoFit/>
+          </a:bodyPr>
+          <a:lstStyle/>
+          <a:p>
+            <a:pPr algn="l"/>
+            <a:r>
+              <a:rPr sz="950" b="0" i="0">
                 <a:solidFill>
                   <a:srgbClr val="1C1C1E"/>
                 </a:solidFill>
                 <a:latin typeface="Helvetica Neue"/>
               </a:rPr>
-              <a:t>Visualización del historial de ánimo</a:t>
+              <a:t>Login sin contraseña → 400</a:t>
             </a:r>
           </a:p>
         </p:txBody>
@@ -8014,8 +8014,8 @@
         </p:nvSpPr>
         <p:spPr>
           <a:xfrm>
-            <a:off x="6400800" y="5303520"/>
-            <a:ext cx="365760" cy="475488"/>
+            <a:off x="6400800" y="3931920"/>
+            <a:ext cx="365760" cy="292608"/>
           </a:xfrm>
           <a:prstGeom prst="rect">
             <a:avLst/>
@@ -8030,7 +8030,7 @@
           <a:p>
             <a:pPr algn="ctr"/>
             <a:r>
-              <a:rPr sz="1000" b="1" i="0">
+              <a:rPr sz="900" b="1" i="0">
                 <a:solidFill>
                   <a:srgbClr val="2C6E49"/>
                 </a:solidFill>
@@ -8049,78 +8049,708 @@
         </p:nvSpPr>
         <p:spPr>
           <a:xfrm>
+            <a:off x="1005840" y="4251960"/>
+            <a:ext cx="822960" cy="292608"/>
+          </a:xfrm>
+          <a:prstGeom prst="rect">
+            <a:avLst/>
+          </a:prstGeom>
+          <a:noFill/>
+        </p:spPr>
+        <p:txBody>
+          <a:bodyPr wrap="square">
+            <a:spAutoFit/>
+          </a:bodyPr>
+          <a:lstStyle/>
+          <a:p>
+            <a:pPr algn="l"/>
+            <a:r>
+              <a:rPr sz="850" b="1" i="0">
+                <a:solidFill>
+                  <a:srgbClr val="2C6E49"/>
+                </a:solidFill>
+                <a:latin typeface="Helvetica Neue"/>
+              </a:rPr>
+              <a:t>T-08</a:t>
+            </a:r>
+          </a:p>
+        </p:txBody>
+      </p:sp>
+      <p:sp>
+        <p:nvSpPr>
+          <p:cNvPr id="28" name="TextBox 27"/>
+          <p:cNvSpPr txBox="1"/>
+          <p:nvPr/>
+        </p:nvSpPr>
+        <p:spPr>
+          <a:xfrm>
+            <a:off x="1828800" y="4251960"/>
+            <a:ext cx="4572000" cy="292608"/>
+          </a:xfrm>
+          <a:prstGeom prst="rect">
+            <a:avLst/>
+          </a:prstGeom>
+          <a:noFill/>
+        </p:spPr>
+        <p:txBody>
+          <a:bodyPr wrap="square">
+            <a:spAutoFit/>
+          </a:bodyPr>
+          <a:lstStyle/>
+          <a:p>
+            <a:pPr algn="l"/>
+            <a:r>
+              <a:rPr sz="950" b="0" i="0">
+                <a:solidFill>
+                  <a:srgbClr val="1C1C1E"/>
+                </a:solidFill>
+                <a:latin typeface="Helvetica Neue"/>
+              </a:rPr>
+              <a:t>GET /api/me sin token → 401</a:t>
+            </a:r>
+          </a:p>
+        </p:txBody>
+      </p:sp>
+      <p:sp>
+        <p:nvSpPr>
+          <p:cNvPr id="29" name="TextBox 28"/>
+          <p:cNvSpPr txBox="1"/>
+          <p:nvPr/>
+        </p:nvSpPr>
+        <p:spPr>
+          <a:xfrm>
+            <a:off x="6400800" y="4251960"/>
+            <a:ext cx="365760" cy="292608"/>
+          </a:xfrm>
+          <a:prstGeom prst="rect">
+            <a:avLst/>
+          </a:prstGeom>
+          <a:noFill/>
+        </p:spPr>
+        <p:txBody>
+          <a:bodyPr wrap="square">
+            <a:spAutoFit/>
+          </a:bodyPr>
+          <a:lstStyle/>
+          <a:p>
+            <a:pPr algn="ctr"/>
+            <a:r>
+              <a:rPr sz="900" b="1" i="0">
+                <a:solidFill>
+                  <a:srgbClr val="2C6E49"/>
+                </a:solidFill>
+                <a:latin typeface="Helvetica Neue"/>
+              </a:rPr>
+              <a:t>✓</a:t>
+            </a:r>
+          </a:p>
+        </p:txBody>
+      </p:sp>
+      <p:sp>
+        <p:nvSpPr>
+          <p:cNvPr id="30" name="TextBox 29"/>
+          <p:cNvSpPr txBox="1"/>
+          <p:nvPr/>
+        </p:nvSpPr>
+        <p:spPr>
+          <a:xfrm>
+            <a:off x="1005840" y="4572000"/>
+            <a:ext cx="822960" cy="292608"/>
+          </a:xfrm>
+          <a:prstGeom prst="rect">
+            <a:avLst/>
+          </a:prstGeom>
+          <a:noFill/>
+        </p:spPr>
+        <p:txBody>
+          <a:bodyPr wrap="square">
+            <a:spAutoFit/>
+          </a:bodyPr>
+          <a:lstStyle/>
+          <a:p>
+            <a:pPr algn="l"/>
+            <a:r>
+              <a:rPr sz="850" b="1" i="0">
+                <a:solidFill>
+                  <a:srgbClr val="2C6E49"/>
+                </a:solidFill>
+                <a:latin typeface="Helvetica Neue"/>
+              </a:rPr>
+              <a:t>T-09</a:t>
+            </a:r>
+          </a:p>
+        </p:txBody>
+      </p:sp>
+      <p:sp>
+        <p:nvSpPr>
+          <p:cNvPr id="31" name="TextBox 30"/>
+          <p:cNvSpPr txBox="1"/>
+          <p:nvPr/>
+        </p:nvSpPr>
+        <p:spPr>
+          <a:xfrm>
+            <a:off x="1828800" y="4572000"/>
+            <a:ext cx="4572000" cy="292608"/>
+          </a:xfrm>
+          <a:prstGeom prst="rect">
+            <a:avLst/>
+          </a:prstGeom>
+          <a:noFill/>
+        </p:spPr>
+        <p:txBody>
+          <a:bodyPr wrap="square">
+            <a:spAutoFit/>
+          </a:bodyPr>
+          <a:lstStyle/>
+          <a:p>
+            <a:pPr algn="l"/>
+            <a:r>
+              <a:rPr sz="950" b="0" i="0">
+                <a:solidFill>
+                  <a:srgbClr val="1C1C1E"/>
+                </a:solidFill>
+                <a:latin typeface="Helvetica Neue"/>
+              </a:rPr>
+              <a:t>GET /api/me con sesión → 200</a:t>
+            </a:r>
+          </a:p>
+        </p:txBody>
+      </p:sp>
+      <p:sp>
+        <p:nvSpPr>
+          <p:cNvPr id="32" name="TextBox 31"/>
+          <p:cNvSpPr txBox="1"/>
+          <p:nvPr/>
+        </p:nvSpPr>
+        <p:spPr>
+          <a:xfrm>
+            <a:off x="6400800" y="4572000"/>
+            <a:ext cx="365760" cy="292608"/>
+          </a:xfrm>
+          <a:prstGeom prst="rect">
+            <a:avLst/>
+          </a:prstGeom>
+          <a:noFill/>
+        </p:spPr>
+        <p:txBody>
+          <a:bodyPr wrap="square">
+            <a:spAutoFit/>
+          </a:bodyPr>
+          <a:lstStyle/>
+          <a:p>
+            <a:pPr algn="ctr"/>
+            <a:r>
+              <a:rPr sz="900" b="1" i="0">
+                <a:solidFill>
+                  <a:srgbClr val="2C6E49"/>
+                </a:solidFill>
+                <a:latin typeface="Helvetica Neue"/>
+              </a:rPr>
+              <a:t>✓</a:t>
+            </a:r>
+          </a:p>
+        </p:txBody>
+      </p:sp>
+      <p:sp>
+        <p:nvSpPr>
+          <p:cNvPr id="33" name="TextBox 32"/>
+          <p:cNvSpPr txBox="1"/>
+          <p:nvPr/>
+        </p:nvSpPr>
+        <p:spPr>
+          <a:xfrm>
+            <a:off x="1005840" y="4892040"/>
+            <a:ext cx="822960" cy="292608"/>
+          </a:xfrm>
+          <a:prstGeom prst="rect">
+            <a:avLst/>
+          </a:prstGeom>
+          <a:noFill/>
+        </p:spPr>
+        <p:txBody>
+          <a:bodyPr wrap="square">
+            <a:spAutoFit/>
+          </a:bodyPr>
+          <a:lstStyle/>
+          <a:p>
+            <a:pPr algn="l"/>
+            <a:r>
+              <a:rPr sz="850" b="1" i="0">
+                <a:solidFill>
+                  <a:srgbClr val="2C6E49"/>
+                </a:solidFill>
+                <a:latin typeface="Helvetica Neue"/>
+              </a:rPr>
+              <a:t>T-10</a:t>
+            </a:r>
+          </a:p>
+        </p:txBody>
+      </p:sp>
+      <p:sp>
+        <p:nvSpPr>
+          <p:cNvPr id="34" name="TextBox 33"/>
+          <p:cNvSpPr txBox="1"/>
+          <p:nvPr/>
+        </p:nvSpPr>
+        <p:spPr>
+          <a:xfrm>
+            <a:off x="1828800" y="4892040"/>
+            <a:ext cx="4572000" cy="292608"/>
+          </a:xfrm>
+          <a:prstGeom prst="rect">
+            <a:avLst/>
+          </a:prstGeom>
+          <a:noFill/>
+        </p:spPr>
+        <p:txBody>
+          <a:bodyPr wrap="square">
+            <a:spAutoFit/>
+          </a:bodyPr>
+          <a:lstStyle/>
+          <a:p>
+            <a:pPr algn="l"/>
+            <a:r>
+              <a:rPr sz="950" b="0" i="0">
+                <a:solidFill>
+                  <a:srgbClr val="1C1C1E"/>
+                </a:solidFill>
+                <a:latin typeface="Helvetica Neue"/>
+              </a:rPr>
+              <a:t>Logout · limpia cookie</a:t>
+            </a:r>
+          </a:p>
+        </p:txBody>
+      </p:sp>
+      <p:sp>
+        <p:nvSpPr>
+          <p:cNvPr id="35" name="TextBox 34"/>
+          <p:cNvSpPr txBox="1"/>
+          <p:nvPr/>
+        </p:nvSpPr>
+        <p:spPr>
+          <a:xfrm>
+            <a:off x="6400800" y="4892040"/>
+            <a:ext cx="365760" cy="292608"/>
+          </a:xfrm>
+          <a:prstGeom prst="rect">
+            <a:avLst/>
+          </a:prstGeom>
+          <a:noFill/>
+        </p:spPr>
+        <p:txBody>
+          <a:bodyPr wrap="square">
+            <a:spAutoFit/>
+          </a:bodyPr>
+          <a:lstStyle/>
+          <a:p>
+            <a:pPr algn="ctr"/>
+            <a:r>
+              <a:rPr sz="900" b="1" i="0">
+                <a:solidFill>
+                  <a:srgbClr val="2C6E49"/>
+                </a:solidFill>
+                <a:latin typeface="Helvetica Neue"/>
+              </a:rPr>
+              <a:t>✓</a:t>
+            </a:r>
+          </a:p>
+        </p:txBody>
+      </p:sp>
+      <p:sp>
+        <p:nvSpPr>
+          <p:cNvPr id="36" name="TextBox 35"/>
+          <p:cNvSpPr txBox="1"/>
+          <p:nvPr/>
+        </p:nvSpPr>
+        <p:spPr>
+          <a:xfrm>
+            <a:off x="1005840" y="5212080"/>
+            <a:ext cx="822960" cy="292608"/>
+          </a:xfrm>
+          <a:prstGeom prst="rect">
+            <a:avLst/>
+          </a:prstGeom>
+          <a:noFill/>
+        </p:spPr>
+        <p:txBody>
+          <a:bodyPr wrap="square">
+            <a:spAutoFit/>
+          </a:bodyPr>
+          <a:lstStyle/>
+          <a:p>
+            <a:pPr algn="l"/>
+            <a:r>
+              <a:rPr sz="850" b="1" i="0">
+                <a:solidFill>
+                  <a:srgbClr val="2C6E49"/>
+                </a:solidFill>
+                <a:latin typeface="Helvetica Neue"/>
+              </a:rPr>
+              <a:t>T-11</a:t>
+            </a:r>
+          </a:p>
+        </p:txBody>
+      </p:sp>
+      <p:sp>
+        <p:nvSpPr>
+          <p:cNvPr id="37" name="TextBox 36"/>
+          <p:cNvSpPr txBox="1"/>
+          <p:nvPr/>
+        </p:nvSpPr>
+        <p:spPr>
+          <a:xfrm>
+            <a:off x="1828800" y="5212080"/>
+            <a:ext cx="4572000" cy="292608"/>
+          </a:xfrm>
+          <a:prstGeom prst="rect">
+            <a:avLst/>
+          </a:prstGeom>
+          <a:noFill/>
+        </p:spPr>
+        <p:txBody>
+          <a:bodyPr wrap="square">
+            <a:spAutoFit/>
+          </a:bodyPr>
+          <a:lstStyle/>
+          <a:p>
+            <a:pPr algn="l"/>
+            <a:r>
+              <a:rPr sz="950" b="0" i="0">
+                <a:solidFill>
+                  <a:srgbClr val="1C1C1E"/>
+                </a:solidFill>
+                <a:latin typeface="Helvetica Neue"/>
+              </a:rPr>
+              <a:t>GET /api/users/logs sin token → 401</a:t>
+            </a:r>
+          </a:p>
+        </p:txBody>
+      </p:sp>
+      <p:sp>
+        <p:nvSpPr>
+          <p:cNvPr id="38" name="TextBox 37"/>
+          <p:cNvSpPr txBox="1"/>
+          <p:nvPr/>
+        </p:nvSpPr>
+        <p:spPr>
+          <a:xfrm>
+            <a:off x="6400800" y="5212080"/>
+            <a:ext cx="365760" cy="292608"/>
+          </a:xfrm>
+          <a:prstGeom prst="rect">
+            <a:avLst/>
+          </a:prstGeom>
+          <a:noFill/>
+        </p:spPr>
+        <p:txBody>
+          <a:bodyPr wrap="square">
+            <a:spAutoFit/>
+          </a:bodyPr>
+          <a:lstStyle/>
+          <a:p>
+            <a:pPr algn="ctr"/>
+            <a:r>
+              <a:rPr sz="900" b="1" i="0">
+                <a:solidFill>
+                  <a:srgbClr val="2C6E49"/>
+                </a:solidFill>
+                <a:latin typeface="Helvetica Neue"/>
+              </a:rPr>
+              <a:t>✓</a:t>
+            </a:r>
+          </a:p>
+        </p:txBody>
+      </p:sp>
+      <p:sp>
+        <p:nvSpPr>
+          <p:cNvPr id="39" name="TextBox 38"/>
+          <p:cNvSpPr txBox="1"/>
+          <p:nvPr/>
+        </p:nvSpPr>
+        <p:spPr>
+          <a:xfrm>
+            <a:off x="1005840" y="5532120"/>
+            <a:ext cx="822960" cy="292608"/>
+          </a:xfrm>
+          <a:prstGeom prst="rect">
+            <a:avLst/>
+          </a:prstGeom>
+          <a:noFill/>
+        </p:spPr>
+        <p:txBody>
+          <a:bodyPr wrap="square">
+            <a:spAutoFit/>
+          </a:bodyPr>
+          <a:lstStyle/>
+          <a:p>
+            <a:pPr algn="l"/>
+            <a:r>
+              <a:rPr sz="850" b="1" i="0">
+                <a:solidFill>
+                  <a:srgbClr val="2C6E49"/>
+                </a:solidFill>
+                <a:latin typeface="Helvetica Neue"/>
+              </a:rPr>
+              <a:t>T-12</a:t>
+            </a:r>
+          </a:p>
+        </p:txBody>
+      </p:sp>
+      <p:sp>
+        <p:nvSpPr>
+          <p:cNvPr id="40" name="TextBox 39"/>
+          <p:cNvSpPr txBox="1"/>
+          <p:nvPr/>
+        </p:nvSpPr>
+        <p:spPr>
+          <a:xfrm>
+            <a:off x="1828800" y="5532120"/>
+            <a:ext cx="4572000" cy="292608"/>
+          </a:xfrm>
+          <a:prstGeom prst="rect">
+            <a:avLst/>
+          </a:prstGeom>
+          <a:noFill/>
+        </p:spPr>
+        <p:txBody>
+          <a:bodyPr wrap="square">
+            <a:spAutoFit/>
+          </a:bodyPr>
+          <a:lstStyle/>
+          <a:p>
+            <a:pPr algn="l"/>
+            <a:r>
+              <a:rPr sz="950" b="0" i="0">
+                <a:solidFill>
+                  <a:srgbClr val="1C1C1E"/>
+                </a:solidFill>
+                <a:latin typeface="Helvetica Neue"/>
+              </a:rPr>
+              <a:t>POST /api/users/moods sin token → 401</a:t>
+            </a:r>
+          </a:p>
+        </p:txBody>
+      </p:sp>
+      <p:sp>
+        <p:nvSpPr>
+          <p:cNvPr id="41" name="TextBox 40"/>
+          <p:cNvSpPr txBox="1"/>
+          <p:nvPr/>
+        </p:nvSpPr>
+        <p:spPr>
+          <a:xfrm>
+            <a:off x="6400800" y="5532120"/>
+            <a:ext cx="365760" cy="292608"/>
+          </a:xfrm>
+          <a:prstGeom prst="rect">
+            <a:avLst/>
+          </a:prstGeom>
+          <a:noFill/>
+        </p:spPr>
+        <p:txBody>
+          <a:bodyPr wrap="square">
+            <a:spAutoFit/>
+          </a:bodyPr>
+          <a:lstStyle/>
+          <a:p>
+            <a:pPr algn="ctr"/>
+            <a:r>
+              <a:rPr sz="900" b="1" i="0">
+                <a:solidFill>
+                  <a:srgbClr val="2C6E49"/>
+                </a:solidFill>
+                <a:latin typeface="Helvetica Neue"/>
+              </a:rPr>
+              <a:t>✓</a:t>
+            </a:r>
+          </a:p>
+        </p:txBody>
+      </p:sp>
+      <p:sp>
+        <p:nvSpPr>
+          <p:cNvPr id="42" name="TextBox 41"/>
+          <p:cNvSpPr txBox="1"/>
+          <p:nvPr/>
+        </p:nvSpPr>
+        <p:spPr>
+          <a:xfrm>
+            <a:off x="1005840" y="5852159"/>
+            <a:ext cx="822960" cy="292608"/>
+          </a:xfrm>
+          <a:prstGeom prst="rect">
+            <a:avLst/>
+          </a:prstGeom>
+          <a:noFill/>
+        </p:spPr>
+        <p:txBody>
+          <a:bodyPr wrap="square">
+            <a:spAutoFit/>
+          </a:bodyPr>
+          <a:lstStyle/>
+          <a:p>
+            <a:pPr algn="l"/>
+            <a:r>
+              <a:rPr sz="850" b="1" i="0">
+                <a:solidFill>
+                  <a:srgbClr val="2C6E49"/>
+                </a:solidFill>
+                <a:latin typeface="Helvetica Neue"/>
+              </a:rPr>
+              <a:t>T-13</a:t>
+            </a:r>
+          </a:p>
+        </p:txBody>
+      </p:sp>
+      <p:sp>
+        <p:nvSpPr>
+          <p:cNvPr id="43" name="TextBox 42"/>
+          <p:cNvSpPr txBox="1"/>
+          <p:nvPr/>
+        </p:nvSpPr>
+        <p:spPr>
+          <a:xfrm>
+            <a:off x="1828800" y="5852159"/>
+            <a:ext cx="4572000" cy="292608"/>
+          </a:xfrm>
+          <a:prstGeom prst="rect">
+            <a:avLst/>
+          </a:prstGeom>
+          <a:noFill/>
+        </p:spPr>
+        <p:txBody>
+          <a:bodyPr wrap="square">
+            <a:spAutoFit/>
+          </a:bodyPr>
+          <a:lstStyle/>
+          <a:p>
+            <a:pPr algn="l"/>
+            <a:r>
+              <a:rPr sz="950" b="0" i="0">
+                <a:solidFill>
+                  <a:srgbClr val="1C1C1E"/>
+                </a:solidFill>
+                <a:latin typeface="Helvetica Neue"/>
+              </a:rPr>
+              <a:t>GET /api/habits sin token → 401</a:t>
+            </a:r>
+          </a:p>
+        </p:txBody>
+      </p:sp>
+      <p:sp>
+        <p:nvSpPr>
+          <p:cNvPr id="44" name="TextBox 43"/>
+          <p:cNvSpPr txBox="1"/>
+          <p:nvPr/>
+        </p:nvSpPr>
+        <p:spPr>
+          <a:xfrm>
+            <a:off x="6400800" y="5852159"/>
+            <a:ext cx="365760" cy="292608"/>
+          </a:xfrm>
+          <a:prstGeom prst="rect">
+            <a:avLst/>
+          </a:prstGeom>
+          <a:noFill/>
+        </p:spPr>
+        <p:txBody>
+          <a:bodyPr wrap="square">
+            <a:spAutoFit/>
+          </a:bodyPr>
+          <a:lstStyle/>
+          <a:p>
+            <a:pPr algn="ctr"/>
+            <a:r>
+              <a:rPr sz="900" b="1" i="0">
+                <a:solidFill>
+                  <a:srgbClr val="2C6E49"/>
+                </a:solidFill>
+                <a:latin typeface="Helvetica Neue"/>
+              </a:rPr>
+              <a:t>✓</a:t>
+            </a:r>
+          </a:p>
+        </p:txBody>
+      </p:sp>
+      <p:sp>
+        <p:nvSpPr>
+          <p:cNvPr id="45" name="TextBox 44"/>
+          <p:cNvSpPr txBox="1"/>
+          <p:nvPr/>
+        </p:nvSpPr>
+        <p:spPr>
+          <a:xfrm>
             <a:off x="6492240" y="2011680"/>
-            <a:ext cx="822960" cy="475488"/>
-          </a:xfrm>
-          <a:prstGeom prst="rect">
-            <a:avLst/>
-          </a:prstGeom>
-          <a:noFill/>
-        </p:spPr>
-        <p:txBody>
-          <a:bodyPr wrap="square">
-            <a:spAutoFit/>
-          </a:bodyPr>
-          <a:lstStyle/>
-          <a:p>
-            <a:pPr algn="l"/>
-            <a:r>
-              <a:rPr sz="950" b="1" i="0">
+            <a:ext cx="822960" cy="292608"/>
+          </a:xfrm>
+          <a:prstGeom prst="rect">
+            <a:avLst/>
+          </a:prstGeom>
+          <a:noFill/>
+        </p:spPr>
+        <p:txBody>
+          <a:bodyPr wrap="square">
+            <a:spAutoFit/>
+          </a:bodyPr>
+          <a:lstStyle/>
+          <a:p>
+            <a:pPr algn="l"/>
+            <a:r>
+              <a:rPr sz="850" b="1" i="0">
                 <a:solidFill>
                   <a:srgbClr val="2C6E49"/>
                 </a:solidFill>
                 <a:latin typeface="Helvetica Neue"/>
               </a:rPr>
-              <a:t>CP-08</a:t>
-            </a:r>
-          </a:p>
-        </p:txBody>
-      </p:sp>
-      <p:sp>
-        <p:nvSpPr>
-          <p:cNvPr id="28" name="TextBox 27"/>
+              <a:t>T-14</a:t>
+            </a:r>
+          </a:p>
+        </p:txBody>
+      </p:sp>
+      <p:sp>
+        <p:nvSpPr>
+          <p:cNvPr id="46" name="TextBox 45"/>
           <p:cNvSpPr txBox="1"/>
           <p:nvPr/>
         </p:nvSpPr>
         <p:spPr>
           <a:xfrm>
             <a:off x="7315200" y="2011680"/>
-            <a:ext cx="4572000" cy="475488"/>
-          </a:xfrm>
-          <a:prstGeom prst="rect">
-            <a:avLst/>
-          </a:prstGeom>
-          <a:noFill/>
-        </p:spPr>
-        <p:txBody>
-          <a:bodyPr wrap="square">
-            <a:spAutoFit/>
-          </a:bodyPr>
-          <a:lstStyle/>
-          <a:p>
-            <a:pPr algn="l"/>
-            <a:r>
-              <a:rPr sz="1050" b="0" i="0">
+            <a:ext cx="4572000" cy="292608"/>
+          </a:xfrm>
+          <a:prstGeom prst="rect">
+            <a:avLst/>
+          </a:prstGeom>
+          <a:noFill/>
+        </p:spPr>
+        <p:txBody>
+          <a:bodyPr wrap="square">
+            <a:spAutoFit/>
+          </a:bodyPr>
+          <a:lstStyle/>
+          <a:p>
+            <a:pPr algn="l"/>
+            <a:r>
+              <a:rPr sz="950" b="0" i="0">
                 <a:solidFill>
                   <a:srgbClr val="1C1C1E"/>
                 </a:solidFill>
                 <a:latin typeface="Helvetica Neue"/>
               </a:rPr>
-              <a:t>Eliminación de una entrada de historial</a:t>
-            </a:r>
-          </a:p>
-        </p:txBody>
-      </p:sp>
-      <p:sp>
-        <p:nvSpPr>
-          <p:cNvPr id="29" name="TextBox 28"/>
+              <a:t>GET /api/habits → catálogo con opciones</a:t>
+            </a:r>
+          </a:p>
+        </p:txBody>
+      </p:sp>
+      <p:sp>
+        <p:nvSpPr>
+          <p:cNvPr id="47" name="TextBox 46"/>
           <p:cNvSpPr txBox="1"/>
           <p:nvPr/>
         </p:nvSpPr>
         <p:spPr>
           <a:xfrm>
             <a:off x="11887200" y="2011680"/>
-            <a:ext cx="365760" cy="475488"/>
+            <a:ext cx="365760" cy="292608"/>
           </a:xfrm>
           <a:prstGeom prst="rect">
             <a:avLst/>
@@ -8135,7 +8765,7 @@
           <a:p>
             <a:pPr algn="ctr"/>
             <a:r>
-              <a:rPr sz="1000" b="1" i="0">
+              <a:rPr sz="900" b="1" i="0">
                 <a:solidFill>
                   <a:srgbClr val="2C6E49"/>
                 </a:solidFill>
@@ -8148,84 +8778,84 @@
       </p:sp>
       <p:sp>
         <p:nvSpPr>
-          <p:cNvPr id="30" name="TextBox 29"/>
-          <p:cNvSpPr txBox="1"/>
-          <p:nvPr/>
-        </p:nvSpPr>
-        <p:spPr>
-          <a:xfrm>
-            <a:off x="6492240" y="2560320"/>
-            <a:ext cx="822960" cy="475488"/>
-          </a:xfrm>
-          <a:prstGeom prst="rect">
-            <a:avLst/>
-          </a:prstGeom>
-          <a:noFill/>
-        </p:spPr>
-        <p:txBody>
-          <a:bodyPr wrap="square">
-            <a:spAutoFit/>
-          </a:bodyPr>
-          <a:lstStyle/>
-          <a:p>
-            <a:pPr algn="l"/>
-            <a:r>
-              <a:rPr sz="950" b="1" i="0">
+          <p:cNvPr id="48" name="TextBox 47"/>
+          <p:cNvSpPr txBox="1"/>
+          <p:nvPr/>
+        </p:nvSpPr>
+        <p:spPr>
+          <a:xfrm>
+            <a:off x="6492240" y="2331720"/>
+            <a:ext cx="822960" cy="292608"/>
+          </a:xfrm>
+          <a:prstGeom prst="rect">
+            <a:avLst/>
+          </a:prstGeom>
+          <a:noFill/>
+        </p:spPr>
+        <p:txBody>
+          <a:bodyPr wrap="square">
+            <a:spAutoFit/>
+          </a:bodyPr>
+          <a:lstStyle/>
+          <a:p>
+            <a:pPr algn="l"/>
+            <a:r>
+              <a:rPr sz="850" b="1" i="0">
                 <a:solidFill>
                   <a:srgbClr val="2C6E49"/>
                 </a:solidFill>
                 <a:latin typeface="Helvetica Neue"/>
               </a:rPr>
-              <a:t>CP-09</a:t>
-            </a:r>
-          </a:p>
-        </p:txBody>
-      </p:sp>
-      <p:sp>
-        <p:nvSpPr>
-          <p:cNvPr id="31" name="TextBox 30"/>
-          <p:cNvSpPr txBox="1"/>
-          <p:nvPr/>
-        </p:nvSpPr>
-        <p:spPr>
-          <a:xfrm>
-            <a:off x="7315200" y="2560320"/>
-            <a:ext cx="4572000" cy="475488"/>
-          </a:xfrm>
-          <a:prstGeom prst="rect">
-            <a:avLst/>
-          </a:prstGeom>
-          <a:noFill/>
-        </p:spPr>
-        <p:txBody>
-          <a:bodyPr wrap="square">
-            <a:spAutoFit/>
-          </a:bodyPr>
-          <a:lstStyle/>
-          <a:p>
-            <a:pPr algn="l"/>
-            <a:r>
-              <a:rPr sz="1050" b="0" i="0">
+              <a:t>T-15</a:t>
+            </a:r>
+          </a:p>
+        </p:txBody>
+      </p:sp>
+      <p:sp>
+        <p:nvSpPr>
+          <p:cNvPr id="49" name="TextBox 48"/>
+          <p:cNvSpPr txBox="1"/>
+          <p:nvPr/>
+        </p:nvSpPr>
+        <p:spPr>
+          <a:xfrm>
+            <a:off x="7315200" y="2331720"/>
+            <a:ext cx="4572000" cy="292608"/>
+          </a:xfrm>
+          <a:prstGeom prst="rect">
+            <a:avLst/>
+          </a:prstGeom>
+          <a:noFill/>
+        </p:spPr>
+        <p:txBody>
+          <a:bodyPr wrap="square">
+            <a:spAutoFit/>
+          </a:bodyPr>
+          <a:lstStyle/>
+          <a:p>
+            <a:pPr algn="l"/>
+            <a:r>
+              <a:rPr sz="950" b="0" i="0">
                 <a:solidFill>
                   <a:srgbClr val="1C1C1E"/>
                 </a:solidFill>
                 <a:latin typeface="Helvetica Neue"/>
               </a:rPr>
-              <a:t>Registro de hábito · guardado inmediato</a:t>
-            </a:r>
-          </a:p>
-        </p:txBody>
-      </p:sp>
-      <p:sp>
-        <p:nvSpPr>
-          <p:cNvPr id="32" name="TextBox 31"/>
-          <p:cNvSpPr txBox="1"/>
-          <p:nvPr/>
-        </p:nvSpPr>
-        <p:spPr>
-          <a:xfrm>
-            <a:off x="11887200" y="2560320"/>
-            <a:ext cx="365760" cy="475488"/>
+              <a:t>POST moods → entrada creada 201</a:t>
+            </a:r>
+          </a:p>
+        </p:txBody>
+      </p:sp>
+      <p:sp>
+        <p:nvSpPr>
+          <p:cNvPr id="50" name="TextBox 49"/>
+          <p:cNvSpPr txBox="1"/>
+          <p:nvPr/>
+        </p:nvSpPr>
+        <p:spPr>
+          <a:xfrm>
+            <a:off x="11887200" y="2331720"/>
+            <a:ext cx="365760" cy="292608"/>
           </a:xfrm>
           <a:prstGeom prst="rect">
             <a:avLst/>
@@ -8240,7 +8870,7 @@
           <a:p>
             <a:pPr algn="ctr"/>
             <a:r>
-              <a:rPr sz="1000" b="1" i="0">
+              <a:rPr sz="900" b="1" i="0">
                 <a:solidFill>
                   <a:srgbClr val="2C6E49"/>
                 </a:solidFill>
@@ -8253,84 +8883,84 @@
       </p:sp>
       <p:sp>
         <p:nvSpPr>
-          <p:cNvPr id="33" name="TextBox 32"/>
-          <p:cNvSpPr txBox="1"/>
-          <p:nvPr/>
-        </p:nvSpPr>
-        <p:spPr>
-          <a:xfrm>
-            <a:off x="6492240" y="3108960"/>
-            <a:ext cx="822960" cy="475488"/>
-          </a:xfrm>
-          <a:prstGeom prst="rect">
-            <a:avLst/>
-          </a:prstGeom>
-          <a:noFill/>
-        </p:spPr>
-        <p:txBody>
-          <a:bodyPr wrap="square">
-            <a:spAutoFit/>
-          </a:bodyPr>
-          <a:lstStyle/>
-          <a:p>
-            <a:pPr algn="l"/>
-            <a:r>
-              <a:rPr sz="950" b="1" i="0">
+          <p:cNvPr id="51" name="TextBox 50"/>
+          <p:cNvSpPr txBox="1"/>
+          <p:nvPr/>
+        </p:nvSpPr>
+        <p:spPr>
+          <a:xfrm>
+            <a:off x="6492240" y="2651760"/>
+            <a:ext cx="822960" cy="292608"/>
+          </a:xfrm>
+          <a:prstGeom prst="rect">
+            <a:avLst/>
+          </a:prstGeom>
+          <a:noFill/>
+        </p:spPr>
+        <p:txBody>
+          <a:bodyPr wrap="square">
+            <a:spAutoFit/>
+          </a:bodyPr>
+          <a:lstStyle/>
+          <a:p>
+            <a:pPr algn="l"/>
+            <a:r>
+              <a:rPr sz="850" b="1" i="0">
                 <a:solidFill>
                   <a:srgbClr val="2C6E49"/>
                 </a:solidFill>
                 <a:latin typeface="Helvetica Neue"/>
               </a:rPr>
-              <a:t>CP-10</a:t>
-            </a:r>
-          </a:p>
-        </p:txBody>
-      </p:sp>
-      <p:sp>
-        <p:nvSpPr>
-          <p:cNvPr id="34" name="TextBox 33"/>
-          <p:cNvSpPr txBox="1"/>
-          <p:nvPr/>
-        </p:nvSpPr>
-        <p:spPr>
-          <a:xfrm>
-            <a:off x="7315200" y="3108960"/>
-            <a:ext cx="4572000" cy="475488"/>
-          </a:xfrm>
-          <a:prstGeom prst="rect">
-            <a:avLst/>
-          </a:prstGeom>
-          <a:noFill/>
-        </p:spPr>
-        <p:txBody>
-          <a:bodyPr wrap="square">
-            <a:spAutoFit/>
-          </a:bodyPr>
-          <a:lstStyle/>
-          <a:p>
-            <a:pPr algn="l"/>
-            <a:r>
-              <a:rPr sz="1050" b="0" i="0">
+              <a:t>T-16</a:t>
+            </a:r>
+          </a:p>
+        </p:txBody>
+      </p:sp>
+      <p:sp>
+        <p:nvSpPr>
+          <p:cNvPr id="52" name="TextBox 51"/>
+          <p:cNvSpPr txBox="1"/>
+          <p:nvPr/>
+        </p:nvSpPr>
+        <p:spPr>
+          <a:xfrm>
+            <a:off x="7315200" y="2651760"/>
+            <a:ext cx="4572000" cy="292608"/>
+          </a:xfrm>
+          <a:prstGeom prst="rect">
+            <a:avLst/>
+          </a:prstGeom>
+          <a:noFill/>
+        </p:spPr>
+        <p:txBody>
+          <a:bodyPr wrap="square">
+            <a:spAutoFit/>
+          </a:bodyPr>
+          <a:lstStyle/>
+          <a:p>
+            <a:pPr algn="l"/>
+            <a:r>
+              <a:rPr sz="950" b="0" i="0">
                 <a:solidFill>
                   <a:srgbClr val="1C1C1E"/>
                 </a:solidFill>
                 <a:latin typeface="Helvetica Neue"/>
               </a:rPr>
-              <a:t>Actualización de hábito ya registrado (upsert)</a:t>
-            </a:r>
-          </a:p>
-        </p:txBody>
-      </p:sp>
-      <p:sp>
-        <p:nvSpPr>
-          <p:cNvPr id="35" name="TextBox 34"/>
-          <p:cNvSpPr txBox="1"/>
-          <p:nvPr/>
-        </p:nvSpPr>
-        <p:spPr>
-          <a:xfrm>
-            <a:off x="11887200" y="3108960"/>
-            <a:ext cx="365760" cy="475488"/>
+              <a:t>GET logs → historial del usuario</a:t>
+            </a:r>
+          </a:p>
+        </p:txBody>
+      </p:sp>
+      <p:sp>
+        <p:nvSpPr>
+          <p:cNvPr id="53" name="TextBox 52"/>
+          <p:cNvSpPr txBox="1"/>
+          <p:nvPr/>
+        </p:nvSpPr>
+        <p:spPr>
+          <a:xfrm>
+            <a:off x="11887200" y="2651760"/>
+            <a:ext cx="365760" cy="292608"/>
           </a:xfrm>
           <a:prstGeom prst="rect">
             <a:avLst/>
@@ -8345,7 +8975,7 @@
           <a:p>
             <a:pPr algn="ctr"/>
             <a:r>
-              <a:rPr sz="1000" b="1" i="0">
+              <a:rPr sz="900" b="1" i="0">
                 <a:solidFill>
                   <a:srgbClr val="2C6E49"/>
                 </a:solidFill>
@@ -8358,84 +8988,84 @@
       </p:sp>
       <p:sp>
         <p:nvSpPr>
-          <p:cNvPr id="36" name="TextBox 35"/>
-          <p:cNvSpPr txBox="1"/>
-          <p:nvPr/>
-        </p:nvSpPr>
-        <p:spPr>
-          <a:xfrm>
-            <a:off x="6492240" y="3657600"/>
-            <a:ext cx="822960" cy="475488"/>
-          </a:xfrm>
-          <a:prstGeom prst="rect">
-            <a:avLst/>
-          </a:prstGeom>
-          <a:noFill/>
-        </p:spPr>
-        <p:txBody>
-          <a:bodyPr wrap="square">
-            <a:spAutoFit/>
-          </a:bodyPr>
-          <a:lstStyle/>
-          <a:p>
-            <a:pPr algn="l"/>
-            <a:r>
-              <a:rPr sz="950" b="1" i="0">
+          <p:cNvPr id="54" name="TextBox 53"/>
+          <p:cNvSpPr txBox="1"/>
+          <p:nvPr/>
+        </p:nvSpPr>
+        <p:spPr>
+          <a:xfrm>
+            <a:off x="6492240" y="2971800"/>
+            <a:ext cx="822960" cy="292608"/>
+          </a:xfrm>
+          <a:prstGeom prst="rect">
+            <a:avLst/>
+          </a:prstGeom>
+          <a:noFill/>
+        </p:spPr>
+        <p:txBody>
+          <a:bodyPr wrap="square">
+            <a:spAutoFit/>
+          </a:bodyPr>
+          <a:lstStyle/>
+          <a:p>
+            <a:pPr algn="l"/>
+            <a:r>
+              <a:rPr sz="850" b="1" i="0">
                 <a:solidFill>
                   <a:srgbClr val="2C6E49"/>
                 </a:solidFill>
                 <a:latin typeface="Helvetica Neue"/>
               </a:rPr>
-              <a:t>CP-11</a:t>
-            </a:r>
-          </a:p>
-        </p:txBody>
-      </p:sp>
-      <p:sp>
-        <p:nvSpPr>
-          <p:cNvPr id="37" name="TextBox 36"/>
-          <p:cNvSpPr txBox="1"/>
-          <p:nvPr/>
-        </p:nvSpPr>
-        <p:spPr>
-          <a:xfrm>
-            <a:off x="7315200" y="3657600"/>
-            <a:ext cx="4572000" cy="475488"/>
-          </a:xfrm>
-          <a:prstGeom prst="rect">
-            <a:avLst/>
-          </a:prstGeom>
-          <a:noFill/>
-        </p:spPr>
-        <p:txBody>
-          <a:bodyPr wrap="square">
-            <a:spAutoFit/>
-          </a:bodyPr>
-          <a:lstStyle/>
-          <a:p>
-            <a:pPr algn="l"/>
-            <a:r>
-              <a:rPr sz="1050" b="0" i="0">
+              <a:t>T-17</a:t>
+            </a:r>
+          </a:p>
+        </p:txBody>
+      </p:sp>
+      <p:sp>
+        <p:nvSpPr>
+          <p:cNvPr id="55" name="TextBox 54"/>
+          <p:cNvSpPr txBox="1"/>
+          <p:nvPr/>
+        </p:nvSpPr>
+        <p:spPr>
+          <a:xfrm>
+            <a:off x="7315200" y="2971800"/>
+            <a:ext cx="4572000" cy="292608"/>
+          </a:xfrm>
+          <a:prstGeom prst="rect">
+            <a:avLst/>
+          </a:prstGeom>
+          <a:noFill/>
+        </p:spPr>
+        <p:txBody>
+          <a:bodyPr wrap="square">
+            <a:spAutoFit/>
+          </a:bodyPr>
+          <a:lstStyle/>
+          <a:p>
+            <a:pPr algn="l"/>
+            <a:r>
+              <a:rPr sz="950" b="0" i="0">
                 <a:solidFill>
                   <a:srgbClr val="1C1C1E"/>
                 </a:solidFill>
                 <a:latin typeface="Helvetica Neue"/>
               </a:rPr>
-              <a:t>Visualización de hábitos del día actual</a:t>
-            </a:r>
-          </a:p>
-        </p:txBody>
-      </p:sp>
-      <p:sp>
-        <p:nvSpPr>
-          <p:cNvPr id="38" name="TextBox 37"/>
-          <p:cNvSpPr txBox="1"/>
-          <p:nvPr/>
-        </p:nvSpPr>
-        <p:spPr>
-          <a:xfrm>
-            <a:off x="11887200" y="3657600"/>
-            <a:ext cx="365760" cy="475488"/>
+              <a:t>POST moods sin campos → 400</a:t>
+            </a:r>
+          </a:p>
+        </p:txBody>
+      </p:sp>
+      <p:sp>
+        <p:nvSpPr>
+          <p:cNvPr id="56" name="TextBox 55"/>
+          <p:cNvSpPr txBox="1"/>
+          <p:nvPr/>
+        </p:nvSpPr>
+        <p:spPr>
+          <a:xfrm>
+            <a:off x="11887200" y="2971800"/>
+            <a:ext cx="365760" cy="292608"/>
           </a:xfrm>
           <a:prstGeom prst="rect">
             <a:avLst/>
@@ -8450,7 +9080,7 @@
           <a:p>
             <a:pPr algn="ctr"/>
             <a:r>
-              <a:rPr sz="1000" b="1" i="0">
+              <a:rPr sz="900" b="1" i="0">
                 <a:solidFill>
                   <a:srgbClr val="2C6E49"/>
                 </a:solidFill>
@@ -8463,84 +9093,84 @@
       </p:sp>
       <p:sp>
         <p:nvSpPr>
-          <p:cNvPr id="39" name="TextBox 38"/>
-          <p:cNvSpPr txBox="1"/>
-          <p:nvPr/>
-        </p:nvSpPr>
-        <p:spPr>
-          <a:xfrm>
-            <a:off x="6492240" y="4206240"/>
-            <a:ext cx="822960" cy="475488"/>
-          </a:xfrm>
-          <a:prstGeom prst="rect">
-            <a:avLst/>
-          </a:prstGeom>
-          <a:noFill/>
-        </p:spPr>
-        <p:txBody>
-          <a:bodyPr wrap="square">
-            <a:spAutoFit/>
-          </a:bodyPr>
-          <a:lstStyle/>
-          <a:p>
-            <a:pPr algn="l"/>
-            <a:r>
-              <a:rPr sz="950" b="1" i="0">
+          <p:cNvPr id="57" name="TextBox 56"/>
+          <p:cNvSpPr txBox="1"/>
+          <p:nvPr/>
+        </p:nvSpPr>
+        <p:spPr>
+          <a:xfrm>
+            <a:off x="6492240" y="3291840"/>
+            <a:ext cx="822960" cy="292608"/>
+          </a:xfrm>
+          <a:prstGeom prst="rect">
+            <a:avLst/>
+          </a:prstGeom>
+          <a:noFill/>
+        </p:spPr>
+        <p:txBody>
+          <a:bodyPr wrap="square">
+            <a:spAutoFit/>
+          </a:bodyPr>
+          <a:lstStyle/>
+          <a:p>
+            <a:pPr algn="l"/>
+            <a:r>
+              <a:rPr sz="850" b="1" i="0">
                 <a:solidFill>
                   <a:srgbClr val="2C6E49"/>
                 </a:solidFill>
                 <a:latin typeface="Helvetica Neue"/>
               </a:rPr>
-              <a:t>CP-12</a:t>
-            </a:r>
-          </a:p>
-        </p:txBody>
-      </p:sp>
-      <p:sp>
-        <p:nvSpPr>
-          <p:cNvPr id="40" name="TextBox 39"/>
-          <p:cNvSpPr txBox="1"/>
-          <p:nvPr/>
-        </p:nvSpPr>
-        <p:spPr>
-          <a:xfrm>
-            <a:off x="7315200" y="4206240"/>
-            <a:ext cx="4572000" cy="475488"/>
-          </a:xfrm>
-          <a:prstGeom prst="rect">
-            <a:avLst/>
-          </a:prstGeom>
-          <a:noFill/>
-        </p:spPr>
-        <p:txBody>
-          <a:bodyPr wrap="square">
-            <a:spAutoFit/>
-          </a:bodyPr>
-          <a:lstStyle/>
-          <a:p>
-            <a:pPr algn="l"/>
-            <a:r>
-              <a:rPr sz="1050" b="0" i="0">
+              <a:t>T-18</a:t>
+            </a:r>
+          </a:p>
+        </p:txBody>
+      </p:sp>
+      <p:sp>
+        <p:nvSpPr>
+          <p:cNvPr id="58" name="TextBox 57"/>
+          <p:cNvSpPr txBox="1"/>
+          <p:nvPr/>
+        </p:nvSpPr>
+        <p:spPr>
+          <a:xfrm>
+            <a:off x="7315200" y="3291840"/>
+            <a:ext cx="4572000" cy="292608"/>
+          </a:xfrm>
+          <a:prstGeom prst="rect">
+            <a:avLst/>
+          </a:prstGeom>
+          <a:noFill/>
+        </p:spPr>
+        <p:txBody>
+          <a:bodyPr wrap="square">
+            <a:spAutoFit/>
+          </a:bodyPr>
+          <a:lstStyle/>
+          <a:p>
+            <a:pPr algn="l"/>
+            <a:r>
+              <a:rPr sz="950" b="0" i="0">
                 <a:solidFill>
                   <a:srgbClr val="1C1C1E"/>
                 </a:solidFill>
                 <a:latin typeface="Helvetica Neue"/>
               </a:rPr>
-              <a:t>Actualización de datos de perfil</a:t>
-            </a:r>
-          </a:p>
-        </p:txBody>
-      </p:sp>
-      <p:sp>
-        <p:nvSpPr>
-          <p:cNvPr id="41" name="TextBox 40"/>
-          <p:cNvSpPr txBox="1"/>
-          <p:nvPr/>
-        </p:nvSpPr>
-        <p:spPr>
-          <a:xfrm>
-            <a:off x="11887200" y="4206240"/>
-            <a:ext cx="365760" cy="475488"/>
+              <a:t>DELETE mood propio → 200</a:t>
+            </a:r>
+          </a:p>
+        </p:txBody>
+      </p:sp>
+      <p:sp>
+        <p:nvSpPr>
+          <p:cNvPr id="59" name="TextBox 58"/>
+          <p:cNvSpPr txBox="1"/>
+          <p:nvPr/>
+        </p:nvSpPr>
+        <p:spPr>
+          <a:xfrm>
+            <a:off x="11887200" y="3291840"/>
+            <a:ext cx="365760" cy="292608"/>
           </a:xfrm>
           <a:prstGeom prst="rect">
             <a:avLst/>
@@ -8555,7 +9185,7 @@
           <a:p>
             <a:pPr algn="ctr"/>
             <a:r>
-              <a:rPr sz="1000" b="1" i="0">
+              <a:rPr sz="900" b="1" i="0">
                 <a:solidFill>
                   <a:srgbClr val="2C6E49"/>
                 </a:solidFill>
@@ -8568,84 +9198,84 @@
       </p:sp>
       <p:sp>
         <p:nvSpPr>
-          <p:cNvPr id="42" name="TextBox 41"/>
-          <p:cNvSpPr txBox="1"/>
-          <p:nvPr/>
-        </p:nvSpPr>
-        <p:spPr>
-          <a:xfrm>
-            <a:off x="6492240" y="4754880"/>
-            <a:ext cx="822960" cy="475488"/>
-          </a:xfrm>
-          <a:prstGeom prst="rect">
-            <a:avLst/>
-          </a:prstGeom>
-          <a:noFill/>
-        </p:spPr>
-        <p:txBody>
-          <a:bodyPr wrap="square">
-            <a:spAutoFit/>
-          </a:bodyPr>
-          <a:lstStyle/>
-          <a:p>
-            <a:pPr algn="l"/>
-            <a:r>
-              <a:rPr sz="950" b="1" i="0">
+          <p:cNvPr id="60" name="TextBox 59"/>
+          <p:cNvSpPr txBox="1"/>
+          <p:nvPr/>
+        </p:nvSpPr>
+        <p:spPr>
+          <a:xfrm>
+            <a:off x="6492240" y="3611880"/>
+            <a:ext cx="822960" cy="292608"/>
+          </a:xfrm>
+          <a:prstGeom prst="rect">
+            <a:avLst/>
+          </a:prstGeom>
+          <a:noFill/>
+        </p:spPr>
+        <p:txBody>
+          <a:bodyPr wrap="square">
+            <a:spAutoFit/>
+          </a:bodyPr>
+          <a:lstStyle/>
+          <a:p>
+            <a:pPr algn="l"/>
+            <a:r>
+              <a:rPr sz="850" b="1" i="0">
                 <a:solidFill>
                   <a:srgbClr val="2C6E49"/>
                 </a:solidFill>
                 <a:latin typeface="Helvetica Neue"/>
               </a:rPr>
-              <a:t>CP-13</a:t>
-            </a:r>
-          </a:p>
-        </p:txBody>
-      </p:sp>
-      <p:sp>
-        <p:nvSpPr>
-          <p:cNvPr id="43" name="TextBox 42"/>
-          <p:cNvSpPr txBox="1"/>
-          <p:nvPr/>
-        </p:nvSpPr>
-        <p:spPr>
-          <a:xfrm>
-            <a:off x="7315200" y="4754880"/>
-            <a:ext cx="4572000" cy="475488"/>
-          </a:xfrm>
-          <a:prstGeom prst="rect">
-            <a:avLst/>
-          </a:prstGeom>
-          <a:noFill/>
-        </p:spPr>
-        <p:txBody>
-          <a:bodyPr wrap="square">
-            <a:spAutoFit/>
-          </a:bodyPr>
-          <a:lstStyle/>
-          <a:p>
-            <a:pPr algn="l"/>
-            <a:r>
-              <a:rPr sz="1050" b="0" i="0">
+              <a:t>T-19</a:t>
+            </a:r>
+          </a:p>
+        </p:txBody>
+      </p:sp>
+      <p:sp>
+        <p:nvSpPr>
+          <p:cNvPr id="61" name="TextBox 60"/>
+          <p:cNvSpPr txBox="1"/>
+          <p:nvPr/>
+        </p:nvSpPr>
+        <p:spPr>
+          <a:xfrm>
+            <a:off x="7315200" y="3611880"/>
+            <a:ext cx="4572000" cy="292608"/>
+          </a:xfrm>
+          <a:prstGeom prst="rect">
+            <a:avLst/>
+          </a:prstGeom>
+          <a:noFill/>
+        </p:spPr>
+        <p:txBody>
+          <a:bodyPr wrap="square">
+            <a:spAutoFit/>
+          </a:bodyPr>
+          <a:lstStyle/>
+          <a:p>
+            <a:pPr algn="l"/>
+            <a:r>
+              <a:rPr sz="950" b="0" i="0">
                 <a:solidFill>
                   <a:srgbClr val="1C1C1E"/>
                 </a:solidFill>
                 <a:latin typeface="Helvetica Neue"/>
               </a:rPr>
-              <a:t>Cambio de contraseña con verificación correcta</a:t>
-            </a:r>
-          </a:p>
-        </p:txBody>
-      </p:sp>
-      <p:sp>
-        <p:nvSpPr>
-          <p:cNvPr id="44" name="TextBox 43"/>
-          <p:cNvSpPr txBox="1"/>
-          <p:nvPr/>
-        </p:nvSpPr>
-        <p:spPr>
-          <a:xfrm>
-            <a:off x="11887200" y="4754880"/>
-            <a:ext cx="365760" cy="475488"/>
+              <a:t>DELETE mood inexistente → 404</a:t>
+            </a:r>
+          </a:p>
+        </p:txBody>
+      </p:sp>
+      <p:sp>
+        <p:nvSpPr>
+          <p:cNvPr id="62" name="TextBox 61"/>
+          <p:cNvSpPr txBox="1"/>
+          <p:nvPr/>
+        </p:nvSpPr>
+        <p:spPr>
+          <a:xfrm>
+            <a:off x="11887200" y="3611880"/>
+            <a:ext cx="365760" cy="292608"/>
           </a:xfrm>
           <a:prstGeom prst="rect">
             <a:avLst/>
@@ -8660,7 +9290,7 @@
           <a:p>
             <a:pPr algn="ctr"/>
             <a:r>
-              <a:rPr sz="1000" b="1" i="0">
+              <a:rPr sz="900" b="1" i="0">
                 <a:solidFill>
                   <a:srgbClr val="2C6E49"/>
                 </a:solidFill>
@@ -8673,84 +9303,84 @@
       </p:sp>
       <p:sp>
         <p:nvSpPr>
-          <p:cNvPr id="45" name="TextBox 44"/>
-          <p:cNvSpPr txBox="1"/>
-          <p:nvPr/>
-        </p:nvSpPr>
-        <p:spPr>
-          <a:xfrm>
-            <a:off x="6492240" y="5303520"/>
-            <a:ext cx="822960" cy="475488"/>
-          </a:xfrm>
-          <a:prstGeom prst="rect">
-            <a:avLst/>
-          </a:prstGeom>
-          <a:noFill/>
-        </p:spPr>
-        <p:txBody>
-          <a:bodyPr wrap="square">
-            <a:spAutoFit/>
-          </a:bodyPr>
-          <a:lstStyle/>
-          <a:p>
-            <a:pPr algn="l"/>
-            <a:r>
-              <a:rPr sz="950" b="1" i="0">
+          <p:cNvPr id="63" name="TextBox 62"/>
+          <p:cNvSpPr txBox="1"/>
+          <p:nvPr/>
+        </p:nvSpPr>
+        <p:spPr>
+          <a:xfrm>
+            <a:off x="6492240" y="3931920"/>
+            <a:ext cx="822960" cy="292608"/>
+          </a:xfrm>
+          <a:prstGeom prst="rect">
+            <a:avLst/>
+          </a:prstGeom>
+          <a:noFill/>
+        </p:spPr>
+        <p:txBody>
+          <a:bodyPr wrap="square">
+            <a:spAutoFit/>
+          </a:bodyPr>
+          <a:lstStyle/>
+          <a:p>
+            <a:pPr algn="l"/>
+            <a:r>
+              <a:rPr sz="850" b="1" i="0">
                 <a:solidFill>
                   <a:srgbClr val="2C6E49"/>
                 </a:solidFill>
                 <a:latin typeface="Helvetica Neue"/>
               </a:rPr>
-              <a:t>CP-14</a:t>
-            </a:r>
-          </a:p>
-        </p:txBody>
-      </p:sp>
-      <p:sp>
-        <p:nvSpPr>
-          <p:cNvPr id="46" name="TextBox 45"/>
-          <p:cNvSpPr txBox="1"/>
-          <p:nvPr/>
-        </p:nvSpPr>
-        <p:spPr>
-          <a:xfrm>
-            <a:off x="7315200" y="5303520"/>
-            <a:ext cx="4572000" cy="475488"/>
-          </a:xfrm>
-          <a:prstGeom prst="rect">
-            <a:avLst/>
-          </a:prstGeom>
-          <a:noFill/>
-        </p:spPr>
-        <p:txBody>
-          <a:bodyPr wrap="square">
-            <a:spAutoFit/>
-          </a:bodyPr>
-          <a:lstStyle/>
-          <a:p>
-            <a:pPr algn="l"/>
-            <a:r>
-              <a:rPr sz="1050" b="0" i="0">
+              <a:t>T-20</a:t>
+            </a:r>
+          </a:p>
+        </p:txBody>
+      </p:sp>
+      <p:sp>
+        <p:nvSpPr>
+          <p:cNvPr id="64" name="TextBox 63"/>
+          <p:cNvSpPr txBox="1"/>
+          <p:nvPr/>
+        </p:nvSpPr>
+        <p:spPr>
+          <a:xfrm>
+            <a:off x="7315200" y="3931920"/>
+            <a:ext cx="4572000" cy="292608"/>
+          </a:xfrm>
+          <a:prstGeom prst="rect">
+            <a:avLst/>
+          </a:prstGeom>
+          <a:noFill/>
+        </p:spPr>
+        <p:txBody>
+          <a:bodyPr wrap="square">
+            <a:spAutoFit/>
+          </a:bodyPr>
+          <a:lstStyle/>
+          <a:p>
+            <a:pPr algn="l"/>
+            <a:r>
+              <a:rPr sz="950" b="0" i="0">
                 <a:solidFill>
                   <a:srgbClr val="1C1C1E"/>
                 </a:solidFill>
                 <a:latin typeface="Helvetica Neue"/>
               </a:rPr>
-              <a:t>Logout · invalidación de sesión</a:t>
-            </a:r>
-          </a:p>
-        </p:txBody>
-      </p:sp>
-      <p:sp>
-        <p:nvSpPr>
-          <p:cNvPr id="47" name="TextBox 46"/>
-          <p:cNvSpPr txBox="1"/>
-          <p:nvPr/>
-        </p:nvSpPr>
-        <p:spPr>
-          <a:xfrm>
-            <a:off x="11887200" y="5303520"/>
-            <a:ext cx="365760" cy="475488"/>
+              <a:t>POST habits/logs → hábito registrado 201</a:t>
+            </a:r>
+          </a:p>
+        </p:txBody>
+      </p:sp>
+      <p:sp>
+        <p:nvSpPr>
+          <p:cNvPr id="65" name="TextBox 64"/>
+          <p:cNvSpPr txBox="1"/>
+          <p:nvPr/>
+        </p:nvSpPr>
+        <p:spPr>
+          <a:xfrm>
+            <a:off x="11887200" y="3931920"/>
+            <a:ext cx="365760" cy="292608"/>
           </a:xfrm>
           <a:prstGeom prst="rect">
             <a:avLst/>
@@ -8765,7 +9395,532 @@
           <a:p>
             <a:pPr algn="ctr"/>
             <a:r>
-              <a:rPr sz="1000" b="1" i="0">
+              <a:rPr sz="900" b="1" i="0">
+                <a:solidFill>
+                  <a:srgbClr val="2C6E49"/>
+                </a:solidFill>
+                <a:latin typeface="Helvetica Neue"/>
+              </a:rPr>
+              <a:t>✓</a:t>
+            </a:r>
+          </a:p>
+        </p:txBody>
+      </p:sp>
+      <p:sp>
+        <p:nvSpPr>
+          <p:cNvPr id="66" name="TextBox 65"/>
+          <p:cNvSpPr txBox="1"/>
+          <p:nvPr/>
+        </p:nvSpPr>
+        <p:spPr>
+          <a:xfrm>
+            <a:off x="6492240" y="4251960"/>
+            <a:ext cx="822960" cy="292608"/>
+          </a:xfrm>
+          <a:prstGeom prst="rect">
+            <a:avLst/>
+          </a:prstGeom>
+          <a:noFill/>
+        </p:spPr>
+        <p:txBody>
+          <a:bodyPr wrap="square">
+            <a:spAutoFit/>
+          </a:bodyPr>
+          <a:lstStyle/>
+          <a:p>
+            <a:pPr algn="l"/>
+            <a:r>
+              <a:rPr sz="850" b="1" i="0">
+                <a:solidFill>
+                  <a:srgbClr val="2C6E49"/>
+                </a:solidFill>
+                <a:latin typeface="Helvetica Neue"/>
+              </a:rPr>
+              <a:t>T-21</a:t>
+            </a:r>
+          </a:p>
+        </p:txBody>
+      </p:sp>
+      <p:sp>
+        <p:nvSpPr>
+          <p:cNvPr id="67" name="TextBox 66"/>
+          <p:cNvSpPr txBox="1"/>
+          <p:nvPr/>
+        </p:nvSpPr>
+        <p:spPr>
+          <a:xfrm>
+            <a:off x="7315200" y="4251960"/>
+            <a:ext cx="4572000" cy="292608"/>
+          </a:xfrm>
+          <a:prstGeom prst="rect">
+            <a:avLst/>
+          </a:prstGeom>
+          <a:noFill/>
+        </p:spPr>
+        <p:txBody>
+          <a:bodyPr wrap="square">
+            <a:spAutoFit/>
+          </a:bodyPr>
+          <a:lstStyle/>
+          <a:p>
+            <a:pPr algn="l"/>
+            <a:r>
+              <a:rPr sz="950" b="0" i="0">
+                <a:solidFill>
+                  <a:srgbClr val="1C1C1E"/>
+                </a:solidFill>
+                <a:latin typeface="Helvetica Neue"/>
+              </a:rPr>
+              <a:t>Upsert: mismo hábito mismo día → 201</a:t>
+            </a:r>
+          </a:p>
+        </p:txBody>
+      </p:sp>
+      <p:sp>
+        <p:nvSpPr>
+          <p:cNvPr id="68" name="TextBox 67"/>
+          <p:cNvSpPr txBox="1"/>
+          <p:nvPr/>
+        </p:nvSpPr>
+        <p:spPr>
+          <a:xfrm>
+            <a:off x="11887200" y="4251960"/>
+            <a:ext cx="365760" cy="292608"/>
+          </a:xfrm>
+          <a:prstGeom prst="rect">
+            <a:avLst/>
+          </a:prstGeom>
+          <a:noFill/>
+        </p:spPr>
+        <p:txBody>
+          <a:bodyPr wrap="square">
+            <a:spAutoFit/>
+          </a:bodyPr>
+          <a:lstStyle/>
+          <a:p>
+            <a:pPr algn="ctr"/>
+            <a:r>
+              <a:rPr sz="900" b="1" i="0">
+                <a:solidFill>
+                  <a:srgbClr val="2C6E49"/>
+                </a:solidFill>
+                <a:latin typeface="Helvetica Neue"/>
+              </a:rPr>
+              <a:t>✓</a:t>
+            </a:r>
+          </a:p>
+        </p:txBody>
+      </p:sp>
+      <p:sp>
+        <p:nvSpPr>
+          <p:cNvPr id="69" name="TextBox 68"/>
+          <p:cNvSpPr txBox="1"/>
+          <p:nvPr/>
+        </p:nvSpPr>
+        <p:spPr>
+          <a:xfrm>
+            <a:off x="6492240" y="4572000"/>
+            <a:ext cx="822960" cy="292608"/>
+          </a:xfrm>
+          <a:prstGeom prst="rect">
+            <a:avLst/>
+          </a:prstGeom>
+          <a:noFill/>
+        </p:spPr>
+        <p:txBody>
+          <a:bodyPr wrap="square">
+            <a:spAutoFit/>
+          </a:bodyPr>
+          <a:lstStyle/>
+          <a:p>
+            <a:pPr algn="l"/>
+            <a:r>
+              <a:rPr sz="850" b="1" i="0">
+                <a:solidFill>
+                  <a:srgbClr val="2C6E49"/>
+                </a:solidFill>
+                <a:latin typeface="Helvetica Neue"/>
+              </a:rPr>
+              <a:t>T-22</a:t>
+            </a:r>
+          </a:p>
+        </p:txBody>
+      </p:sp>
+      <p:sp>
+        <p:nvSpPr>
+          <p:cNvPr id="70" name="TextBox 69"/>
+          <p:cNvSpPr txBox="1"/>
+          <p:nvPr/>
+        </p:nvSpPr>
+        <p:spPr>
+          <a:xfrm>
+            <a:off x="7315200" y="4572000"/>
+            <a:ext cx="4572000" cy="292608"/>
+          </a:xfrm>
+          <a:prstGeom prst="rect">
+            <a:avLst/>
+          </a:prstGeom>
+          <a:noFill/>
+        </p:spPr>
+        <p:txBody>
+          <a:bodyPr wrap="square">
+            <a:spAutoFit/>
+          </a:bodyPr>
+          <a:lstStyle/>
+          <a:p>
+            <a:pPr algn="l"/>
+            <a:r>
+              <a:rPr sz="950" b="0" i="0">
+                <a:solidFill>
+                  <a:srgbClr val="1C1C1E"/>
+                </a:solidFill>
+                <a:latin typeface="Helvetica Neue"/>
+              </a:rPr>
+              <a:t>GET habits/logs/date → hábitos del día</a:t>
+            </a:r>
+          </a:p>
+        </p:txBody>
+      </p:sp>
+      <p:sp>
+        <p:nvSpPr>
+          <p:cNvPr id="71" name="TextBox 70"/>
+          <p:cNvSpPr txBox="1"/>
+          <p:nvPr/>
+        </p:nvSpPr>
+        <p:spPr>
+          <a:xfrm>
+            <a:off x="11887200" y="4572000"/>
+            <a:ext cx="365760" cy="292608"/>
+          </a:xfrm>
+          <a:prstGeom prst="rect">
+            <a:avLst/>
+          </a:prstGeom>
+          <a:noFill/>
+        </p:spPr>
+        <p:txBody>
+          <a:bodyPr wrap="square">
+            <a:spAutoFit/>
+          </a:bodyPr>
+          <a:lstStyle/>
+          <a:p>
+            <a:pPr algn="ctr"/>
+            <a:r>
+              <a:rPr sz="900" b="1" i="0">
+                <a:solidFill>
+                  <a:srgbClr val="2C6E49"/>
+                </a:solidFill>
+                <a:latin typeface="Helvetica Neue"/>
+              </a:rPr>
+              <a:t>✓</a:t>
+            </a:r>
+          </a:p>
+        </p:txBody>
+      </p:sp>
+      <p:sp>
+        <p:nvSpPr>
+          <p:cNvPr id="72" name="TextBox 71"/>
+          <p:cNvSpPr txBox="1"/>
+          <p:nvPr/>
+        </p:nvSpPr>
+        <p:spPr>
+          <a:xfrm>
+            <a:off x="6492240" y="4892040"/>
+            <a:ext cx="822960" cy="292608"/>
+          </a:xfrm>
+          <a:prstGeom prst="rect">
+            <a:avLst/>
+          </a:prstGeom>
+          <a:noFill/>
+        </p:spPr>
+        <p:txBody>
+          <a:bodyPr wrap="square">
+            <a:spAutoFit/>
+          </a:bodyPr>
+          <a:lstStyle/>
+          <a:p>
+            <a:pPr algn="l"/>
+            <a:r>
+              <a:rPr sz="850" b="1" i="0">
+                <a:solidFill>
+                  <a:srgbClr val="2C6E49"/>
+                </a:solidFill>
+                <a:latin typeface="Helvetica Neue"/>
+              </a:rPr>
+              <a:t>T-23</a:t>
+            </a:r>
+          </a:p>
+        </p:txBody>
+      </p:sp>
+      <p:sp>
+        <p:nvSpPr>
+          <p:cNvPr id="73" name="TextBox 72"/>
+          <p:cNvSpPr txBox="1"/>
+          <p:nvPr/>
+        </p:nvSpPr>
+        <p:spPr>
+          <a:xfrm>
+            <a:off x="7315200" y="4892040"/>
+            <a:ext cx="4572000" cy="292608"/>
+          </a:xfrm>
+          <a:prstGeom prst="rect">
+            <a:avLst/>
+          </a:prstGeom>
+          <a:noFill/>
+        </p:spPr>
+        <p:txBody>
+          <a:bodyPr wrap="square">
+            <a:spAutoFit/>
+          </a:bodyPr>
+          <a:lstStyle/>
+          <a:p>
+            <a:pPr algn="l"/>
+            <a:r>
+              <a:rPr sz="950" b="0" i="0">
+                <a:solidFill>
+                  <a:srgbClr val="1C1C1E"/>
+                </a:solidFill>
+                <a:latin typeface="Helvetica Neue"/>
+              </a:rPr>
+              <a:t>POST habits/logs sin campos → 400</a:t>
+            </a:r>
+          </a:p>
+        </p:txBody>
+      </p:sp>
+      <p:sp>
+        <p:nvSpPr>
+          <p:cNvPr id="74" name="TextBox 73"/>
+          <p:cNvSpPr txBox="1"/>
+          <p:nvPr/>
+        </p:nvSpPr>
+        <p:spPr>
+          <a:xfrm>
+            <a:off x="11887200" y="4892040"/>
+            <a:ext cx="365760" cy="292608"/>
+          </a:xfrm>
+          <a:prstGeom prst="rect">
+            <a:avLst/>
+          </a:prstGeom>
+          <a:noFill/>
+        </p:spPr>
+        <p:txBody>
+          <a:bodyPr wrap="square">
+            <a:spAutoFit/>
+          </a:bodyPr>
+          <a:lstStyle/>
+          <a:p>
+            <a:pPr algn="ctr"/>
+            <a:r>
+              <a:rPr sz="900" b="1" i="0">
+                <a:solidFill>
+                  <a:srgbClr val="2C6E49"/>
+                </a:solidFill>
+                <a:latin typeface="Helvetica Neue"/>
+              </a:rPr>
+              <a:t>✓</a:t>
+            </a:r>
+          </a:p>
+        </p:txBody>
+      </p:sp>
+      <p:sp>
+        <p:nvSpPr>
+          <p:cNvPr id="75" name="TextBox 74"/>
+          <p:cNvSpPr txBox="1"/>
+          <p:nvPr/>
+        </p:nvSpPr>
+        <p:spPr>
+          <a:xfrm>
+            <a:off x="6492240" y="5212080"/>
+            <a:ext cx="822960" cy="292608"/>
+          </a:xfrm>
+          <a:prstGeom prst="rect">
+            <a:avLst/>
+          </a:prstGeom>
+          <a:noFill/>
+        </p:spPr>
+        <p:txBody>
+          <a:bodyPr wrap="square">
+            <a:spAutoFit/>
+          </a:bodyPr>
+          <a:lstStyle/>
+          <a:p>
+            <a:pPr algn="l"/>
+            <a:r>
+              <a:rPr sz="850" b="1" i="0">
+                <a:solidFill>
+                  <a:srgbClr val="2C6E49"/>
+                </a:solidFill>
+                <a:latin typeface="Helvetica Neue"/>
+              </a:rPr>
+              <a:t>T-24</a:t>
+            </a:r>
+          </a:p>
+        </p:txBody>
+      </p:sp>
+      <p:sp>
+        <p:nvSpPr>
+          <p:cNvPr id="76" name="TextBox 75"/>
+          <p:cNvSpPr txBox="1"/>
+          <p:nvPr/>
+        </p:nvSpPr>
+        <p:spPr>
+          <a:xfrm>
+            <a:off x="7315200" y="5212080"/>
+            <a:ext cx="4572000" cy="292608"/>
+          </a:xfrm>
+          <a:prstGeom prst="rect">
+            <a:avLst/>
+          </a:prstGeom>
+          <a:noFill/>
+        </p:spPr>
+        <p:txBody>
+          <a:bodyPr wrap="square">
+            <a:spAutoFit/>
+          </a:bodyPr>
+          <a:lstStyle/>
+          <a:p>
+            <a:pPr algn="l"/>
+            <a:r>
+              <a:rPr sz="950" b="0" i="0">
+                <a:solidFill>
+                  <a:srgbClr val="1C1C1E"/>
+                </a:solidFill>
+                <a:latin typeface="Helvetica Neue"/>
+              </a:rPr>
+              <a:t>GET /api/users/profile → 200</a:t>
+            </a:r>
+          </a:p>
+        </p:txBody>
+      </p:sp>
+      <p:sp>
+        <p:nvSpPr>
+          <p:cNvPr id="77" name="TextBox 76"/>
+          <p:cNvSpPr txBox="1"/>
+          <p:nvPr/>
+        </p:nvSpPr>
+        <p:spPr>
+          <a:xfrm>
+            <a:off x="11887200" y="5212080"/>
+            <a:ext cx="365760" cy="292608"/>
+          </a:xfrm>
+          <a:prstGeom prst="rect">
+            <a:avLst/>
+          </a:prstGeom>
+          <a:noFill/>
+        </p:spPr>
+        <p:txBody>
+          <a:bodyPr wrap="square">
+            <a:spAutoFit/>
+          </a:bodyPr>
+          <a:lstStyle/>
+          <a:p>
+            <a:pPr algn="ctr"/>
+            <a:r>
+              <a:rPr sz="900" b="1" i="0">
+                <a:solidFill>
+                  <a:srgbClr val="2C6E49"/>
+                </a:solidFill>
+                <a:latin typeface="Helvetica Neue"/>
+              </a:rPr>
+              <a:t>✓</a:t>
+            </a:r>
+          </a:p>
+        </p:txBody>
+      </p:sp>
+      <p:sp>
+        <p:nvSpPr>
+          <p:cNvPr id="78" name="TextBox 77"/>
+          <p:cNvSpPr txBox="1"/>
+          <p:nvPr/>
+        </p:nvSpPr>
+        <p:spPr>
+          <a:xfrm>
+            <a:off x="6492240" y="5532120"/>
+            <a:ext cx="822960" cy="292608"/>
+          </a:xfrm>
+          <a:prstGeom prst="rect">
+            <a:avLst/>
+          </a:prstGeom>
+          <a:noFill/>
+        </p:spPr>
+        <p:txBody>
+          <a:bodyPr wrap="square">
+            <a:spAutoFit/>
+          </a:bodyPr>
+          <a:lstStyle/>
+          <a:p>
+            <a:pPr algn="l"/>
+            <a:r>
+              <a:rPr sz="850" b="1" i="0">
+                <a:solidFill>
+                  <a:srgbClr val="2C6E49"/>
+                </a:solidFill>
+                <a:latin typeface="Helvetica Neue"/>
+              </a:rPr>
+              <a:t>T-25</a:t>
+            </a:r>
+          </a:p>
+        </p:txBody>
+      </p:sp>
+      <p:sp>
+        <p:nvSpPr>
+          <p:cNvPr id="79" name="TextBox 78"/>
+          <p:cNvSpPr txBox="1"/>
+          <p:nvPr/>
+        </p:nvSpPr>
+        <p:spPr>
+          <a:xfrm>
+            <a:off x="7315200" y="5532120"/>
+            <a:ext cx="4572000" cy="292608"/>
+          </a:xfrm>
+          <a:prstGeom prst="rect">
+            <a:avLst/>
+          </a:prstGeom>
+          <a:noFill/>
+        </p:spPr>
+        <p:txBody>
+          <a:bodyPr wrap="square">
+            <a:spAutoFit/>
+          </a:bodyPr>
+          <a:lstStyle/>
+          <a:p>
+            <a:pPr algn="l"/>
+            <a:r>
+              <a:rPr sz="950" b="0" i="0">
+                <a:solidFill>
+                  <a:srgbClr val="1C1C1E"/>
+                </a:solidFill>
+                <a:latin typeface="Helvetica Neue"/>
+              </a:rPr>
+              <a:t>PUT /api/users/profile → datos actualizados</a:t>
+            </a:r>
+          </a:p>
+        </p:txBody>
+      </p:sp>
+      <p:sp>
+        <p:nvSpPr>
+          <p:cNvPr id="80" name="TextBox 79"/>
+          <p:cNvSpPr txBox="1"/>
+          <p:nvPr/>
+        </p:nvSpPr>
+        <p:spPr>
+          <a:xfrm>
+            <a:off x="11887200" y="5532120"/>
+            <a:ext cx="365760" cy="292608"/>
+          </a:xfrm>
+          <a:prstGeom prst="rect">
+            <a:avLst/>
+          </a:prstGeom>
+          <a:noFill/>
+        </p:spPr>
+        <p:txBody>
+          <a:bodyPr wrap="square">
+            <a:spAutoFit/>
+          </a:bodyPr>
+          <a:lstStyle/>
+          <a:p>
+            <a:pPr algn="ctr"/>
+            <a:r>
+              <a:rPr sz="900" b="1" i="0">
                 <a:solidFill>
                   <a:srgbClr val="2C6E49"/>
                 </a:solidFill>
@@ -9343,7 +10498,7 @@
                 </a:solidFill>
                 <a:latin typeface="Helvetica Neue"/>
               </a:rPr>
-              <a:t>Los 14 casos de prueba validados demuestran la robustez y corrección de todas las funcionalidades.</a:t>
+              <a:t>Los 25 tests de integración automatizados validan todos los endpoints de la API y los flujos críticos.</a:t>
             </a:r>
           </a:p>
         </p:txBody>
@@ -9441,7 +10596,7 @@
             <a:avLst/>
           </a:prstGeom>
           <a:solidFill>
-            <a:srgbClr val="4AA86C"/>
+            <a:srgbClr val="5BBCDD"/>
           </a:solidFill>
           <a:ln>
             <a:noFill/>
@@ -9554,7 +10709,7 @@
             <a:avLst/>
           </a:prstGeom>
           <a:solidFill>
-            <a:srgbClr val="4AA86C"/>
+            <a:srgbClr val="5BBCDD"/>
           </a:solidFill>
           <a:ln>
             <a:noFill/>
@@ -9667,7 +10822,7 @@
             <a:avLst/>
           </a:prstGeom>
           <a:solidFill>
-            <a:srgbClr val="4AA86C"/>
+            <a:srgbClr val="5BBCDD"/>
           </a:solidFill>
           <a:ln>
             <a:noFill/>
@@ -9780,7 +10935,7 @@
             <a:avLst/>
           </a:prstGeom>
           <a:solidFill>
-            <a:srgbClr val="4AA86C"/>
+            <a:srgbClr val="5BBCDD"/>
           </a:solidFill>
           <a:ln>
             <a:noFill/>
@@ -11412,84 +12567,6 @@
           </a:p>
         </p:txBody>
       </p:sp>
-      <p:sp>
-        <p:nvSpPr>
-          <p:cNvPr id="9" name="Rectangle 8"/>
-          <p:cNvSpPr/>
-          <p:nvPr/>
-        </p:nvSpPr>
-        <p:spPr>
-          <a:xfrm>
-            <a:off x="1005840" y="5303520"/>
-            <a:ext cx="73152" cy="822960"/>
-          </a:xfrm>
-          <a:prstGeom prst="rect">
-            <a:avLst/>
-          </a:prstGeom>
-          <a:solidFill>
-            <a:srgbClr val="2C6E49"/>
-          </a:solidFill>
-          <a:ln>
-            <a:noFill/>
-          </a:ln>
-        </p:spPr>
-        <p:style>
-          <a:lnRef idx="1">
-            <a:schemeClr val="accent1"/>
-          </a:lnRef>
-          <a:fillRef idx="3">
-            <a:schemeClr val="accent1"/>
-          </a:fillRef>
-          <a:effectRef idx="2">
-            <a:schemeClr val="accent1"/>
-          </a:effectRef>
-          <a:fontRef idx="minor">
-            <a:schemeClr val="lt1"/>
-          </a:fontRef>
-        </p:style>
-        <p:txBody>
-          <a:bodyPr rtlCol="0" anchor="ctr"/>
-          <a:lstStyle/>
-          <a:p>
-            <a:pPr algn="ctr"/>
-          </a:p>
-        </p:txBody>
-      </p:sp>
-      <p:sp>
-        <p:nvSpPr>
-          <p:cNvPr id="10" name="TextBox 9"/>
-          <p:cNvSpPr txBox="1"/>
-          <p:nvPr/>
-        </p:nvSpPr>
-        <p:spPr>
-          <a:xfrm>
-            <a:off x="1234440" y="5349240"/>
-            <a:ext cx="9601200" cy="640080"/>
-          </a:xfrm>
-          <a:prstGeom prst="rect">
-            <a:avLst/>
-          </a:prstGeom>
-          <a:noFill/>
-        </p:spPr>
-        <p:txBody>
-          <a:bodyPr wrap="square">
-            <a:spAutoFit/>
-          </a:bodyPr>
-          <a:lstStyle/>
-          <a:p>
-            <a:pPr algn="l"/>
-            <a:r>
-              <a:rPr sz="1200" b="0" i="1">
-                <a:solidFill>
-                  <a:srgbClr val="6E6E73"/>
-                </a:solidFill>
-                <a:latin typeface="Helvetica Neue"/>
-              </a:rPr>
-              <a:t>«Cada persona debería ser dueña de sus propios datos de bienestar.»</a:t>
-            </a:r>
-          </a:p>
-        </p:txBody>
-      </p:sp>
     </p:spTree>
   </p:cSld>
   <p:clrMapOvr>
@@ -12458,7 +13535,7 @@
             <a:avLst/>
           </a:prstGeom>
           <a:solidFill>
-            <a:srgbClr val="4AA86C"/>
+            <a:srgbClr val="5BBCDD"/>
           </a:solidFill>
           <a:ln>
             <a:noFill/>
@@ -12536,7 +13613,7 @@
             <a:avLst/>
           </a:prstGeom>
           <a:solidFill>
-            <a:srgbClr val="4AA86C"/>
+            <a:srgbClr val="5BBCDD"/>
           </a:solidFill>
           <a:ln>
             <a:noFill/>
@@ -12614,7 +13691,7 @@
             <a:avLst/>
           </a:prstGeom>
           <a:solidFill>
-            <a:srgbClr val="4AA86C"/>
+            <a:srgbClr val="5BBCDD"/>
           </a:solidFill>
           <a:ln>
             <a:noFill/>
@@ -12692,7 +13769,7 @@
             <a:avLst/>
           </a:prstGeom>
           <a:solidFill>
-            <a:srgbClr val="4AA86C"/>
+            <a:srgbClr val="5BBCDD"/>
           </a:solidFill>
           <a:ln>
             <a:noFill/>
@@ -12891,7 +13968,7 @@
             <a:avLst/>
           </a:prstGeom>
           <a:solidFill>
-            <a:srgbClr val="4AA86C"/>
+            <a:srgbClr val="5BBCDD"/>
           </a:solidFill>
           <a:ln>
             <a:noFill/>
@@ -12969,7 +14046,7 @@
             <a:avLst/>
           </a:prstGeom>
           <a:solidFill>
-            <a:srgbClr val="4AA86C"/>
+            <a:srgbClr val="5BBCDD"/>
           </a:solidFill>
           <a:ln>
             <a:noFill/>
@@ -13047,7 +14124,7 @@
             <a:avLst/>
           </a:prstGeom>
           <a:solidFill>
-            <a:srgbClr val="4AA86C"/>
+            <a:srgbClr val="5BBCDD"/>
           </a:solidFill>
           <a:ln>
             <a:noFill/>
@@ -13125,7 +14202,7 @@
             <a:avLst/>
           </a:prstGeom>
           <a:solidFill>
-            <a:srgbClr val="4AA86C"/>
+            <a:srgbClr val="5BBCDD"/>
           </a:solidFill>
           <a:ln>
             <a:noFill/>
@@ -13324,7 +14401,7 @@
             <a:avLst/>
           </a:prstGeom>
           <a:solidFill>
-            <a:srgbClr val="4AA86C"/>
+            <a:srgbClr val="5BBCDD"/>
           </a:solidFill>
           <a:ln>
             <a:noFill/>
@@ -13402,7 +14479,7 @@
             <a:avLst/>
           </a:prstGeom>
           <a:solidFill>
-            <a:srgbClr val="4AA86C"/>
+            <a:srgbClr val="5BBCDD"/>
           </a:solidFill>
           <a:ln>
             <a:noFill/>
@@ -13480,7 +14557,7 @@
             <a:avLst/>
           </a:prstGeom>
           <a:solidFill>
-            <a:srgbClr val="4AA86C"/>
+            <a:srgbClr val="5BBCDD"/>
           </a:solidFill>
           <a:ln>
             <a:noFill/>
@@ -13679,7 +14756,7 @@
             <a:avLst/>
           </a:prstGeom>
           <a:solidFill>
-            <a:srgbClr val="4AA86C"/>
+            <a:srgbClr val="5BBCDD"/>
           </a:solidFill>
           <a:ln>
             <a:noFill/>
@@ -13757,7 +14834,7 @@
             <a:avLst/>
           </a:prstGeom>
           <a:solidFill>
-            <a:srgbClr val="4AA86C"/>
+            <a:srgbClr val="5BBCDD"/>
           </a:solidFill>
           <a:ln>
             <a:noFill/>
@@ -13835,7 +14912,7 @@
             <a:avLst/>
           </a:prstGeom>
           <a:solidFill>
-            <a:srgbClr val="4AA86C"/>
+            <a:srgbClr val="5BBCDD"/>
           </a:solidFill>
           <a:ln>
             <a:noFill/>
@@ -13913,7 +14990,7 @@
             <a:avLst/>
           </a:prstGeom>
           <a:solidFill>
-            <a:srgbClr val="4AA86C"/>
+            <a:srgbClr val="5BBCDD"/>
           </a:solidFill>
           <a:ln>
             <a:noFill/>
@@ -14286,7 +15363,7 @@
             <a:avLst/>
           </a:prstGeom>
           <a:solidFill>
-            <a:srgbClr val="4AA86C"/>
+            <a:srgbClr val="5BBCDD"/>
           </a:solidFill>
           <a:ln>
             <a:noFill/>

</xml_diff>